<commit_message>
Rebuild the deck in the style of the earlier one: waveforms only
Charts are gone. The error budget, the C_comp sweep and the max|Ku| table were
drawn as a bar chart, a bar chart and a scatter; they looked tidy and told the
reader less than the numbers. Those slides now list the numbers, and every figure
in the deck is a simulation result.

Layout follows the 0825 deck: two or three short bullets stating the point, then
the waveform; pad voltage and the coefficients side by side for the same case; a
bold pipe-separated figure title carrying device, pulse and quantity; the
transistor as a thick pale trace with native IBIS drawn over it; the reversal
marked with a dashed line.

Also fixed by rendering and looking: bullets that ran underneath the figures on
the pair slides, legends sitting on the curves in both pair panels, and a wide
figure crowding the page number.

17 slides became 14.

Co-Authored-By: Claude Opus 5 <noreply@anthropic.com>
</commit_message>
<xml_diff>
--- a/results/meeting_deck_2026-09-04/ibis_pybis_status_2026-09-04.pptx
+++ b/results/meeting_deck_2026-09-04/ibis_pybis_status_2026-09-04.pptx
@@ -22,9 +22,6 @@
     <p:sldId id="267" r:id="rId19"/>
     <p:sldId id="268" r:id="rId20"/>
     <p:sldId id="269" r:id="rId21"/>
-    <p:sldId id="270" r:id="rId22"/>
-    <p:sldId id="271" r:id="rId23"/>
-    <p:sldId id="272" r:id="rId24"/>
   </p:sldIdLst>
   <p:sldSz cx="12192000" cy="6858000"/>
   <p:notesSz cx="6858000" cy="9144000"/>
@@ -673,7 +670,7 @@
           <a:lstStyle/>
           <a:p>
             <a:r>
-              <a:t>Lead with this. Full-swing accuracy is close to as good as the format allows, so effort belongs on truncated pulses.</a:t>
+              <a:t>Lead with this. Full-swing accuracy is close to as good as the format allows, so the effort belongs on truncated pulses.</a:t>
             </a:r>
           </a:p>
         </p:txBody>
@@ -743,7 +740,7 @@
           <a:lstStyle/>
           <a:p>
             <a:r>
-              <a:t>The sign of the stranded charge flips with the timestep, so it is an integration error. Any fix by tuning a coefficient is a coin flip, which is why the retuned version helped on some cases and not others.</a:t>
+              <a:t>Two separate defects. The offset is a settled-state Ku error, on the 90/60/50 targets only -- a ~6 ns tail that looks permanent on a 10 ns plot. The timing shift is the falling 50% crossing 69-99 ps late on every case, where native IBIS is 5-26 ps early.</a:t>
             </a:r>
           </a:p>
         </p:txBody>
@@ -813,7 +810,7 @@
           <a:lstStyle/>
           <a:p>
             <a:r>
-              <a:t>delay_cmd is level-driven: the command is a function of the current input level, not of accumulated edge history, so it returns to exactly zero and strands nothing. On this case the pedestal goes from 97.9 mV to 5.2 mV against the transistor's 2.1 mV. Across all 29 matched stress cases RMSE goes from 108.6 to 92.2 mV, the only build that beats native IBIS.</a:t>
+              <a:t>The sign of the stranded charge flips with the timestep, so it is an integration error. Any fix by tuning a coefficient is a coin flip, which is why the retuned version helped on some cases and not others.</a:t>
             </a:r>
           </a:p>
         </p:txBody>
@@ -883,7 +880,7 @@
           <a:lstStyle/>
           <a:p>
             <a:r>
-              <a:t>State the caveat honestly: delay_cmd has a known 1.25 ns dead zone after a reversal where neither device is commanded on, which is why predriver_cmd was previously preferred.</a:t>
+              <a:t>On this case the pedestal goes from 97.9 mV to 5.2 mV against the transistor's 2.1 mV. Across all 29 matched stress cases RMSE goes from 108.6 to 92.2 mV, the only build that beats native IBIS. Caveat to state: delay_cmd has a 1.25 ns dead zone after a reversal where neither device is commanded on.</a:t>
             </a:r>
           </a:p>
         </p:txBody>
@@ -953,7 +950,147 @@
           <a:lstStyle/>
           <a:p>
             <a:r>
-              <a:t>I proposed the wrong cause first, Miller feedthrough, and built a nomiller variant to test it. It came back identical to the control. Those caps are 20.5 fF against C_comp's 5 pF, 0.41%, 250x too small, which is arithmetic I should have done before building the variant. The null result still rules out the small capacitor and points at C_comp.</a:t>
+              <a:t>I proposed the wrong cause first -- Miller feedthrough -- and built the nomiller variant to test it. It came back identical to the control. Those caps are 20.5 fF against C_comp's 5 pF, 0.41%, 250x too small, which is arithmetic I should have done before building the variant.</a:t>
+            </a:r>
+          </a:p>
+        </p:txBody>
+      </p:sp>
+      <p:sp>
+        <p:nvSpPr>
+          <p:cNvPr id="4" name="Slide Number Placeholder 3"/>
+          <p:cNvSpPr>
+            <a:spLocks noGrp="1"/>
+          </p:cNvSpPr>
+          <p:nvPr>
+            <p:ph type="sldNum" idx="5" sz="quarter"/>
+          </p:nvPr>
+        </p:nvSpPr>
+        <p:spPr/>
+      </p:sp>
+    </p:spTree>
+  </p:cSld>
+  <p:clrMapOvr>
+    <a:masterClrMapping/>
+  </p:clrMapOvr>
+</p:notes>
+</file>
+
+<file path=ppt/notesSlides/notesSlide7.xml><?xml version="1.0" encoding="utf-8"?>
+<p:notes xmlns:a="http://schemas.openxmlformats.org/drawingml/2006/main" xmlns:p="http://schemas.openxmlformats.org/presentationml/2006/main" xmlns:r="http://schemas.openxmlformats.org/officeDocument/2006/relationships">
+  <p:cSld>
+    <p:spTree>
+      <p:nvGrpSpPr>
+        <p:cNvPr id="1" name=""/>
+        <p:cNvGrpSpPr/>
+        <p:nvPr/>
+      </p:nvGrpSpPr>
+      <p:grpSpPr>
+        <a:xfrm>
+          <a:off x="0" y="0"/>
+          <a:ext cx="0" cy="0"/>
+          <a:chOff x="0" y="0"/>
+          <a:chExt cx="0" cy="0"/>
+        </a:xfrm>
+      </p:grpSpPr>
+      <p:sp>
+        <p:nvSpPr>
+          <p:cNvPr id="2" name="Slide Image Placeholder 1"/>
+          <p:cNvSpPr>
+            <a:spLocks noGrp="1"/>
+          </p:cNvSpPr>
+          <p:nvPr>
+            <p:ph type="sldImg" idx="2"/>
+          </p:nvPr>
+        </p:nvSpPr>
+        <p:spPr/>
+      </p:sp>
+      <p:sp>
+        <p:nvSpPr>
+          <p:cNvPr id="3" name="Notes Placeholder 2"/>
+          <p:cNvSpPr>
+            <a:spLocks noGrp="1"/>
+          </p:cNvSpPr>
+          <p:nvPr>
+            <p:ph type="body" idx="3" sz="quarter"/>
+          </p:nvPr>
+        </p:nvSpPr>
+        <p:spPr/>
+        <p:txBody>
+          <a:bodyPr/>
+          <a:lstStyle/>
+          <a:p>
+            <a:r>
+              <a:t>Ku and Kd here come from the transistor itself, by driving it into two fixtures and running the same two-equation solve the model uses. That is a ground-truth coefficient target, not native IBIS's opinion.</a:t>
+            </a:r>
+          </a:p>
+        </p:txBody>
+      </p:sp>
+      <p:sp>
+        <p:nvSpPr>
+          <p:cNvPr id="4" name="Slide Number Placeholder 3"/>
+          <p:cNvSpPr>
+            <a:spLocks noGrp="1"/>
+          </p:cNvSpPr>
+          <p:nvPr>
+            <p:ph type="sldNum" idx="5" sz="quarter"/>
+          </p:nvPr>
+        </p:nvSpPr>
+        <p:spPr/>
+      </p:sp>
+    </p:spTree>
+  </p:cSld>
+  <p:clrMapOvr>
+    <a:masterClrMapping/>
+  </p:clrMapOvr>
+</p:notes>
+</file>
+
+<file path=ppt/notesSlides/notesSlide8.xml><?xml version="1.0" encoding="utf-8"?>
+<p:notes xmlns:a="http://schemas.openxmlformats.org/drawingml/2006/main" xmlns:p="http://schemas.openxmlformats.org/presentationml/2006/main" xmlns:r="http://schemas.openxmlformats.org/officeDocument/2006/relationships">
+  <p:cSld>
+    <p:spTree>
+      <p:nvGrpSpPr>
+        <p:cNvPr id="1" name=""/>
+        <p:cNvGrpSpPr/>
+        <p:nvPr/>
+      </p:nvGrpSpPr>
+      <p:grpSpPr>
+        <a:xfrm>
+          <a:off x="0" y="0"/>
+          <a:ext cx="0" cy="0"/>
+          <a:chOff x="0" y="0"/>
+          <a:chExt cx="0" cy="0"/>
+        </a:xfrm>
+      </p:grpSpPr>
+      <p:sp>
+        <p:nvSpPr>
+          <p:cNvPr id="2" name="Slide Image Placeholder 1"/>
+          <p:cNvSpPr>
+            <a:spLocks noGrp="1"/>
+          </p:cNvSpPr>
+          <p:nvPr>
+            <p:ph type="sldImg" idx="2"/>
+          </p:nvPr>
+        </p:nvSpPr>
+        <p:spPr/>
+      </p:sp>
+      <p:sp>
+        <p:nvSpPr>
+          <p:cNvPr id="3" name="Notes Placeholder 2"/>
+          <p:cNvSpPr>
+            <a:spLocks noGrp="1"/>
+          </p:cNvSpPr>
+          <p:nvPr>
+            <p:ph type="body" idx="3" sz="quarter"/>
+          </p:nvPr>
+        </p:nvSpPr>
+        <p:spPr/>
+        <p:txBody>
+          <a:bodyPr/>
+          <a:lstStyle/>
+          <a:p>
+            <a:r>
+              <a:t>Two rules worth not re-learning: any bench for this model must start with a real edge, never a held level, because it initialises pulldown-on and latches state only on an edge. And ngspice must be converged before drawing any conclusion.</a:t>
             </a:r>
           </a:p>
         </p:txBody>
@@ -2919,7 +3056,7 @@
               </a:defRPr>
             </a:pPr>
             <a:r>
-              <a:t>Getting pybis closer to the transistor</a:t>
+              <a:t>Getting our IBIS model closer to the transistor</a:t>
             </a:r>
           </a:p>
         </p:txBody>
@@ -3024,7 +3161,7 @@
               </a:defRPr>
             </a:pPr>
             <a:r>
-              <a:t>The core reconstruction is sound</a:t>
+              <a:t>Is the difference the engine or the model?</a:t>
             </a:r>
           </a:p>
         </p:txBody>
@@ -3060,7 +3197,7 @@
               </a:defRPr>
             </a:pPr>
             <a:r>
-              <a:t>CONFIDENCE</a:t>
+              <a:t>METHOD</a:t>
             </a:r>
           </a:p>
         </p:txBody>
@@ -3073,8 +3210,8 @@
         </p:nvSpPr>
         <p:spPr>
           <a:xfrm>
-            <a:off x="640080" y="1280160"/>
-            <a:ext cx="6035040" cy="2560320"/>
+            <a:off x="640080" y="1170432"/>
+            <a:ext cx="11064240" cy="685800"/>
           </a:xfrm>
           <a:prstGeom prst="rect">
             <a:avLst/>
@@ -3089,7 +3226,7 @@
           <a:p>
             <a:pPr>
               <a:spcAft>
-                <a:spcPts val="700"/>
+                <a:spcPts val="300"/>
               </a:spcAft>
               <a:defRPr sz="1700">
                 <a:solidFill>
@@ -3099,15 +3236,35 @@
               </a:defRPr>
             </a:pPr>
             <a:r>
-              <a:t>•  A golden-waveform test replays a model's own V-T tables into the fixture that produced them.</a:t>
-            </a:r>
-          </a:p>
-          <a:p>
-            <a:pPr>
-              <a:spcAft>
-                <a:spcPts val="700"/>
-              </a:spcAft>
-              <a:defRPr sz="1700">
+              <a:t>•  Every native-vs-ours number changes two things at once. We wrote a translator so the same model runs in both simulators.</a:t>
+            </a:r>
+          </a:p>
+        </p:txBody>
+      </p:sp>
+      <p:sp>
+        <p:nvSpPr>
+          <p:cNvPr id="5" name="TextBox 4"/>
+          <p:cNvSpPr txBox="1"/>
+          <p:nvPr/>
+        </p:nvSpPr>
+        <p:spPr>
+          <a:xfrm>
+            <a:off x="640080" y="2103120"/>
+            <a:ext cx="10972800" cy="457200"/>
+          </a:xfrm>
+          <a:prstGeom prst="rect">
+            <a:avLst/>
+          </a:prstGeom>
+          <a:noFill/>
+        </p:spPr>
+        <p:txBody>
+          <a:bodyPr wrap="square" lIns="45720" rIns="45720" anchor="t">
+            <a:spAutoFit/>
+          </a:bodyPr>
+          <a:lstStyle/>
+          <a:p>
+            <a:pPr algn="l">
+              <a:defRPr sz="1700" b="0">
                 <a:solidFill>
                   <a:srgbClr val="191F1C"/>
                 </a:solidFill>
@@ -3115,127 +3272,7 @@
               </a:defRPr>
             </a:pPr>
             <a:r>
-              <a:t>•  Self-contained: no transistor, no native IBIS, no engine confound. We had never done this.</a:t>
-            </a:r>
-          </a:p>
-          <a:p>
-            <a:pPr>
-              <a:spcAft>
-                <a:spcPts val="700"/>
-              </a:spcAft>
-              <a:defRPr sz="1700">
-                <a:solidFill>
-                  <a:srgbClr val="191F1C"/>
-                </a:solidFill>
-                <a:latin typeface="Aptos"/>
-              </a:defRPr>
-            </a:pPr>
-            <a:r>
-              <a:t>•  pybis reproduces all three buffers' own golden waveforms.</a:t>
-            </a:r>
-          </a:p>
-        </p:txBody>
-      </p:sp>
-      <p:sp>
-        <p:nvSpPr>
-          <p:cNvPr id="5" name="Rounded Rectangle 4"/>
-          <p:cNvSpPr/>
-          <p:nvPr/>
-        </p:nvSpPr>
-        <p:spPr>
-          <a:xfrm>
-            <a:off x="6858000" y="1371600"/>
-            <a:ext cx="4754880" cy="1591310"/>
-          </a:xfrm>
-          <a:prstGeom prst="roundRect">
-            <a:avLst/>
-          </a:prstGeom>
-          <a:solidFill>
-            <a:srgbClr val="F6F8F7"/>
-          </a:solidFill>
-          <a:ln w="12700">
-            <a:solidFill>
-              <a:srgbClr val="A4AEA8"/>
-            </a:solidFill>
-          </a:ln>
-        </p:spPr>
-        <p:style>
-          <a:lnRef idx="1">
-            <a:schemeClr val="accent1"/>
-          </a:lnRef>
-          <a:fillRef idx="3">
-            <a:schemeClr val="accent1"/>
-          </a:fillRef>
-          <a:effectRef idx="2">
-            <a:schemeClr val="accent1"/>
-          </a:effectRef>
-          <a:fontRef idx="minor">
-            <a:schemeClr val="lt1"/>
-          </a:fontRef>
-        </p:style>
-        <p:txBody>
-          <a:bodyPr rtlCol="0" anchor="t" wrap="none" lIns="118872" rIns="73152" tIns="91440" bIns="73152"/>
-          <a:lstStyle/>
-          <a:p>
-            <a:pPr algn="l">
-              <a:defRPr sz="1700">
-                <a:solidFill>
-                  <a:srgbClr val="1E3027"/>
-                </a:solidFill>
-                <a:latin typeface="Consolas"/>
-              </a:defRPr>
-            </a:pPr>
-            <a:r>
-              <a:t>figure of merit   0.03 - 0.41 %</a:t>
-            </a:r>
-          </a:p>
-          <a:p>
-            <a:pPr algn="l">
-              <a:defRPr sz="1700">
-                <a:solidFill>
-                  <a:srgbClr val="1E3027"/>
-                </a:solidFill>
-                <a:latin typeface="Consolas"/>
-              </a:defRPr>
-            </a:pPr>
-            <a:r>
-              <a:t>timing shift      +4 to +8 ps</a:t>
-            </a:r>
-          </a:p>
-          <a:p>
-            <a:pPr algn="l">
-              <a:defRPr sz="1700">
-                <a:solidFill>
-                  <a:srgbClr val="1E3027"/>
-                </a:solidFill>
-                <a:latin typeface="Consolas"/>
-              </a:defRPr>
-            </a:pPr>
-          </a:p>
-          <a:p>
-            <a:pPr algn="l">
-              <a:defRPr sz="1700">
-                <a:solidFill>
-                  <a:srgbClr val="1E3027"/>
-                </a:solidFill>
-                <a:latin typeface="Consolas"/>
-              </a:defRPr>
-            </a:pPr>
-            <a:r>
-              <a:t>three buffers, both edges,</a:t>
-            </a:r>
-          </a:p>
-          <a:p>
-            <a:pPr algn="l">
-              <a:defRPr sz="1700">
-                <a:solidFill>
-                  <a:srgbClr val="1E3027"/>
-                </a:solidFill>
-                <a:latin typeface="Consolas"/>
-              </a:defRPr>
-            </a:pPr>
-            <a:r>
-              <a:t>both fixtures</a:t>
+              <a:t>Falling 50% crossing:</a:t>
             </a:r>
           </a:p>
         </p:txBody>
@@ -3248,8 +3285,79 @@
         </p:nvSpPr>
         <p:spPr>
           <a:xfrm>
-            <a:off x="640080" y="3291840"/>
-            <a:ext cx="10972800" cy="731520"/>
+            <a:off x="640080" y="2651760"/>
+            <a:ext cx="11064240" cy="2057400"/>
+          </a:xfrm>
+          <a:prstGeom prst="rect">
+            <a:avLst/>
+          </a:prstGeom>
+          <a:noFill/>
+        </p:spPr>
+        <p:txBody>
+          <a:bodyPr wrap="square" lIns="73152" rIns="36576" tIns="36576" bIns="36576">
+            <a:spAutoFit/>
+          </a:bodyPr>
+          <a:lstStyle/>
+          <a:p>
+            <a:pPr>
+              <a:spcAft>
+                <a:spcPts val="300"/>
+              </a:spcAft>
+              <a:defRPr sz="1700">
+                <a:solidFill>
+                  <a:srgbClr val="191F1C"/>
+                </a:solidFill>
+                <a:latin typeface="Aptos"/>
+              </a:defRPr>
+            </a:pPr>
+            <a:r>
+              <a:t>•  our model in ngspice     5.3371 ns</a:t>
+            </a:r>
+          </a:p>
+          <a:p>
+            <a:pPr>
+              <a:spcAft>
+                <a:spcPts val="300"/>
+              </a:spcAft>
+              <a:defRPr sz="1700">
+                <a:solidFill>
+                  <a:srgbClr val="191F1C"/>
+                </a:solidFill>
+                <a:latin typeface="Aptos"/>
+              </a:defRPr>
+            </a:pPr>
+            <a:r>
+              <a:t>•  our model in HSPICE      5.3375 ns     engine:  −0.5 ps</a:t>
+            </a:r>
+          </a:p>
+          <a:p>
+            <a:pPr>
+              <a:spcAft>
+                <a:spcPts val="300"/>
+              </a:spcAft>
+              <a:defRPr sz="1700">
+                <a:solidFill>
+                  <a:srgbClr val="191F1C"/>
+                </a:solidFill>
+                <a:latin typeface="Aptos"/>
+              </a:defRPr>
+            </a:pPr>
+            <a:r>
+              <a:t>•  native IBIS in HSPICE    5.3319 ns     model:   +5.6 ps</a:t>
+            </a:r>
+          </a:p>
+        </p:txBody>
+      </p:sp>
+      <p:sp>
+        <p:nvSpPr>
+          <p:cNvPr id="7" name="TextBox 6"/>
+          <p:cNvSpPr txBox="1"/>
+          <p:nvPr/>
+        </p:nvSpPr>
+        <p:spPr>
+          <a:xfrm>
+            <a:off x="640080" y="4572000"/>
+            <a:ext cx="10972800" cy="914400"/>
           </a:xfrm>
           <a:prstGeom prst="rect">
             <a:avLst/>
@@ -3271,62 +3379,7 @@
               </a:defRPr>
             </a:pPr>
             <a:r>
-              <a:t>It is now the standing health check, and it settled the C_comp question.</a:t>
-            </a:r>
-          </a:p>
-        </p:txBody>
-      </p:sp>
-      <p:sp>
-        <p:nvSpPr>
-          <p:cNvPr id="7" name="Rectangle 6"/>
-          <p:cNvSpPr/>
-          <p:nvPr/>
-        </p:nvSpPr>
-        <p:spPr>
-          <a:xfrm>
-            <a:off x="384048" y="6062472"/>
-            <a:ext cx="11109960" cy="393192"/>
-          </a:xfrm>
-          <a:prstGeom prst="rect">
-            <a:avLst/>
-          </a:prstGeom>
-          <a:solidFill>
-            <a:srgbClr val="F1F8F2"/>
-          </a:solidFill>
-          <a:ln>
-            <a:solidFill>
-              <a:srgbClr val="F1F8F2"/>
-            </a:solidFill>
-          </a:ln>
-        </p:spPr>
-        <p:style>
-          <a:lnRef idx="1">
-            <a:schemeClr val="accent1"/>
-          </a:lnRef>
-          <a:fillRef idx="3">
-            <a:schemeClr val="accent1"/>
-          </a:fillRef>
-          <a:effectRef idx="2">
-            <a:schemeClr val="accent1"/>
-          </a:effectRef>
-          <a:fontRef idx="minor">
-            <a:schemeClr val="lt1"/>
-          </a:fontRef>
-        </p:style>
-        <p:txBody>
-          <a:bodyPr rtlCol="0" anchor="ctr"/>
-          <a:lstStyle/>
-          <a:p>
-            <a:pPr algn="ctr">
-              <a:defRPr sz="1400" b="1">
-                <a:solidFill>
-                  <a:srgbClr val="2B7A43"/>
-                </a:solidFill>
-                <a:latin typeface="Aptos"/>
-              </a:defRPr>
-            </a:pPr>
-            <a:r>
-              <a:t>Whatever is wrong under stress, it is not the I-V times Ku(t) reconstruction.</a:t>
+              <a:t>The engine is not the source — provided ngspice is converged. At a 1 ps step it was an aliasing outlier that doubled the apparent lag.</a:t>
             </a:r>
           </a:p>
         </p:txBody>
@@ -3373,7 +3426,7 @@
               </a:defRPr>
             </a:pPr>
             <a:r>
-              <a:t>C_comp is handled correctly</a:t>
+              <a:t>What fixtures do to the extracted Ku/Kd</a:t>
             </a:r>
           </a:p>
         </p:txBody>
@@ -3409,131 +3462,114 @@
               </a:defRPr>
             </a:pPr>
             <a:r>
-              <a:t>CONFIDENCE</a:t>
-            </a:r>
-          </a:p>
-        </p:txBody>
-      </p:sp>
-      <p:sp>
-        <p:nvSpPr>
-          <p:cNvPr id="4" name="Rectangle 3"/>
-          <p:cNvSpPr/>
+              <a:t>METHOD</a:t>
+            </a:r>
+          </a:p>
+        </p:txBody>
+      </p:sp>
+      <p:sp>
+        <p:nvSpPr>
+          <p:cNvPr id="4" name="TextBox 3"/>
+          <p:cNvSpPr txBox="1"/>
           <p:nvPr/>
         </p:nvSpPr>
         <p:spPr>
           <a:xfrm>
-            <a:off x="475488" y="1143000"/>
-            <a:ext cx="11210544" cy="4809743"/>
-          </a:xfrm>
-          <a:prstGeom prst="rect">
-            <a:avLst/>
-          </a:prstGeom>
-          <a:solidFill>
-            <a:srgbClr val="FFFFFF"/>
-          </a:solidFill>
-          <a:ln w="10160">
-            <a:solidFill>
-              <a:srgbClr val="CBD0CC"/>
-            </a:solidFill>
-          </a:ln>
-        </p:spPr>
-        <p:style>
-          <a:lnRef idx="1">
-            <a:schemeClr val="accent1"/>
-          </a:lnRef>
-          <a:fillRef idx="3">
-            <a:schemeClr val="accent1"/>
-          </a:fillRef>
-          <a:effectRef idx="2">
-            <a:schemeClr val="accent1"/>
-          </a:effectRef>
-          <a:fontRef idx="minor">
-            <a:schemeClr val="lt1"/>
-          </a:fontRef>
-        </p:style>
-        <p:txBody>
-          <a:bodyPr rtlCol="0" anchor="ctr"/>
-          <a:lstStyle/>
-          <a:p>
-            <a:pPr algn="ctr"/>
-          </a:p>
-        </p:txBody>
-      </p:sp>
-      <p:pic>
-        <p:nvPicPr>
-          <p:cNvPr id="5" name="Picture 4" descr="ccomp.png"/>
-          <p:cNvPicPr>
-            <a:picLocks noChangeAspect="1"/>
-          </p:cNvPicPr>
+            <a:off x="640080" y="1170432"/>
+            <a:ext cx="11064240" cy="2057400"/>
+          </a:xfrm>
+          <a:prstGeom prst="rect">
+            <a:avLst/>
+          </a:prstGeom>
+          <a:noFill/>
+        </p:spPr>
+        <p:txBody>
+          <a:bodyPr wrap="square" lIns="73152" rIns="36576" tIns="36576" bIns="36576">
+            <a:spAutoFit/>
+          </a:bodyPr>
+          <a:lstStyle/>
+          <a:p>
+            <a:pPr>
+              <a:spcAft>
+                <a:spcPts val="300"/>
+              </a:spcAft>
+              <a:defRPr sz="1700">
+                <a:solidFill>
+                  <a:srgbClr val="191F1C"/>
+                </a:solidFill>
+                <a:latin typeface="Aptos"/>
+              </a:defRPr>
+            </a:pPr>
+            <a:r>
+              <a:t>•  The control reproduces the shipped solve to 2.4e−08, so the method is exact.</a:t>
+            </a:r>
+          </a:p>
+          <a:p>
+            <a:pPr>
+              <a:spcAft>
+                <a:spcPts val="300"/>
+              </a:spcAft>
+              <a:defRPr sz="1700">
+                <a:solidFill>
+                  <a:srgbClr val="191F1C"/>
+                </a:solidFill>
+                <a:latin typeface="Aptos"/>
+              </a:defRPr>
+            </a:pPr>
+            <a:r>
+              <a:t>•  In quiet regions Ku is load-independent to four decimals — a device property, not a fixture artifact.</a:t>
+            </a:r>
+          </a:p>
+          <a:p>
+            <a:pPr>
+              <a:spcAft>
+                <a:spcPts val="300"/>
+              </a:spcAft>
+              <a:defRPr sz="1700">
+                <a:solidFill>
+                  <a:srgbClr val="191F1C"/>
+                </a:solidFill>
+                <a:latin typeface="Aptos"/>
+              </a:defRPr>
+            </a:pPr>
+            <a:r>
+              <a:t>•  A resonant R+L+C fixture corrupts Ku for 1.14 ns, reaching 0.26 of error.</a:t>
+            </a:r>
+          </a:p>
+        </p:txBody>
+      </p:sp>
+      <p:sp>
+        <p:nvSpPr>
+          <p:cNvPr id="5" name="TextBox 4"/>
+          <p:cNvSpPr txBox="1"/>
           <p:nvPr/>
-        </p:nvPicPr>
-        <p:blipFill>
-          <a:blip r:embed="rId2"/>
-          <a:stretch>
-            <a:fillRect/>
-          </a:stretch>
-        </p:blipFill>
-        <p:spPr>
-          <a:xfrm>
-            <a:off x="502920" y="1170432"/>
-            <a:ext cx="11155680" cy="4754879"/>
-          </a:xfrm>
-          <a:prstGeom prst="rect">
-            <a:avLst/>
-          </a:prstGeom>
-        </p:spPr>
-      </p:pic>
-      <p:sp>
-        <p:nvSpPr>
-          <p:cNvPr id="6" name="Rectangle 5"/>
-          <p:cNvSpPr/>
-          <p:nvPr/>
-        </p:nvSpPr>
-        <p:spPr>
-          <a:xfrm>
-            <a:off x="384048" y="6062472"/>
-            <a:ext cx="11109960" cy="393192"/>
-          </a:xfrm>
-          <a:prstGeom prst="rect">
-            <a:avLst/>
-          </a:prstGeom>
-          <a:solidFill>
-            <a:srgbClr val="F1F8F2"/>
-          </a:solidFill>
-          <a:ln>
-            <a:solidFill>
-              <a:srgbClr val="F1F8F2"/>
-            </a:solidFill>
-          </a:ln>
-        </p:spPr>
-        <p:style>
-          <a:lnRef idx="1">
-            <a:schemeClr val="accent1"/>
-          </a:lnRef>
-          <a:fillRef idx="3">
-            <a:schemeClr val="accent1"/>
-          </a:fillRef>
-          <a:effectRef idx="2">
-            <a:schemeClr val="accent1"/>
-          </a:effectRef>
-          <a:fontRef idx="minor">
-            <a:schemeClr val="lt1"/>
-          </a:fontRef>
-        </p:style>
-        <p:txBody>
-          <a:bodyPr rtlCol="0" anchor="ctr"/>
-          <a:lstStyle/>
-          <a:p>
-            <a:pPr algn="ctr">
-              <a:defRPr sz="1400" b="1">
-                <a:solidFill>
-                  <a:srgbClr val="2B7A43"/>
+        </p:nvSpPr>
+        <p:spPr>
+          <a:xfrm>
+            <a:off x="640080" y="3931920"/>
+            <a:ext cx="10972800" cy="731520"/>
+          </a:xfrm>
+          <a:prstGeom prst="rect">
+            <a:avLst/>
+          </a:prstGeom>
+          <a:noFill/>
+        </p:spPr>
+        <p:txBody>
+          <a:bodyPr wrap="square" lIns="45720" rIns="45720" anchor="t">
+            <a:spAutoFit/>
+          </a:bodyPr>
+          <a:lstStyle/>
+          <a:p>
+            <a:pPr algn="l">
+              <a:defRPr sz="1700" b="0">
+                <a:solidFill>
+                  <a:srgbClr val="191F1C"/>
                 </a:solidFill>
                 <a:latin typeface="Aptos"/>
               </a:defRPr>
             </a:pPr>
             <a:r>
-              <a:t>I had this backwards first. The golden-waveform test overturned my own claim that pybis over-applies C_comp.</a:t>
+              <a:t>Added L and C are safe individually. The resonant combination has to be avoided when characterising.</a:t>
             </a:r>
           </a:p>
         </p:txBody>
@@ -3580,7 +3616,7 @@
               </a:defRPr>
             </a:pPr>
             <a:r>
-              <a:t>Is it the engine or the model?</a:t>
+              <a:t>The 1.25 max|Ku| cap rejects good models</a:t>
             </a:r>
           </a:p>
         </p:txBody>
@@ -3616,7 +3652,7 @@
               </a:defRPr>
             </a:pPr>
             <a:r>
-              <a:t>METHOD</a:t>
+              <a:t>WHAT SHOULD CHANGE</a:t>
             </a:r>
           </a:p>
         </p:txBody>
@@ -3630,7 +3666,7 @@
         <p:spPr>
           <a:xfrm>
             <a:off x="640080" y="1188720"/>
-            <a:ext cx="10972800" cy="914400"/>
+            <a:ext cx="10972800" cy="457200"/>
           </a:xfrm>
           <a:prstGeom prst="rect">
             <a:avLst/>
@@ -3652,111 +3688,110 @@
               </a:defRPr>
             </a:pPr>
             <a:r>
-              <a:t>Every native-vs-pybis number changes two things at once: the IBIS implementation and the SPICE engine. We wrote a translator so the same model runs in both.</a:t>
-            </a:r>
-          </a:p>
-        </p:txBody>
-      </p:sp>
-      <p:sp>
-        <p:nvSpPr>
-          <p:cNvPr id="5" name="Rounded Rectangle 4"/>
-          <p:cNvSpPr/>
+              <a:t>ex2 variants, across all seven characterisation edge rates:</a:t>
+            </a:r>
+          </a:p>
+        </p:txBody>
+      </p:sp>
+      <p:sp>
+        <p:nvSpPr>
+          <p:cNvPr id="5" name="TextBox 4"/>
+          <p:cNvSpPr txBox="1"/>
           <p:nvPr/>
         </p:nvSpPr>
         <p:spPr>
           <a:xfrm>
-            <a:off x="640080" y="2377440"/>
-            <a:ext cx="10972800" cy="1591310"/>
-          </a:xfrm>
-          <a:prstGeom prst="roundRect">
-            <a:avLst/>
-          </a:prstGeom>
-          <a:solidFill>
-            <a:srgbClr val="F6F8F7"/>
-          </a:solidFill>
-          <a:ln w="12700">
-            <a:solidFill>
-              <a:srgbClr val="A4AEA8"/>
-            </a:solidFill>
-          </a:ln>
-        </p:spPr>
-        <p:style>
-          <a:lnRef idx="1">
-            <a:schemeClr val="accent1"/>
-          </a:lnRef>
-          <a:fillRef idx="3">
-            <a:schemeClr val="accent1"/>
-          </a:fillRef>
-          <a:effectRef idx="2">
-            <a:schemeClr val="accent1"/>
-          </a:effectRef>
-          <a:fontRef idx="minor">
-            <a:schemeClr val="lt1"/>
-          </a:fontRef>
-        </p:style>
-        <p:txBody>
-          <a:bodyPr rtlCol="0" anchor="t" wrap="none" lIns="118872" rIns="73152" tIns="91440" bIns="73152"/>
-          <a:lstStyle/>
-          <a:p>
-            <a:pPr algn="l">
+            <a:off x="640080" y="1737360"/>
+            <a:ext cx="11064240" cy="3429000"/>
+          </a:xfrm>
+          <a:prstGeom prst="rect">
+            <a:avLst/>
+          </a:prstGeom>
+          <a:noFill/>
+        </p:spPr>
+        <p:txBody>
+          <a:bodyPr wrap="square" lIns="73152" rIns="36576" tIns="36576" bIns="36576">
+            <a:spAutoFit/>
+          </a:bodyPr>
+          <a:lstStyle/>
+          <a:p>
+            <a:pPr>
+              <a:spcAft>
+                <a:spcPts val="300"/>
+              </a:spcAft>
               <a:defRPr sz="1700">
                 <a:solidFill>
-                  <a:srgbClr val="1E3027"/>
-                </a:solidFill>
-                <a:latin typeface="Consolas"/>
-              </a:defRPr>
-            </a:pPr>
-            <a:r>
-              <a:t>                          50% crossing</a:t>
-            </a:r>
-          </a:p>
-          <a:p>
-            <a:pPr algn="l">
+                  <a:srgbClr val="191F1C"/>
+                </a:solidFill>
+                <a:latin typeface="Aptos"/>
+              </a:defRPr>
+            </a:pPr>
+            <a:r>
+              <a:t>•  slowpre   predriver halved      328 ps      1.047</a:t>
+            </a:r>
+          </a:p>
+          <a:p>
+            <a:pPr>
+              <a:spcAft>
+                <a:spcPts val="300"/>
+              </a:spcAft>
               <a:defRPr sz="1700">
                 <a:solidFill>
-                  <a:srgbClr val="1E3027"/>
-                </a:solidFill>
-                <a:latin typeface="Consolas"/>
-              </a:defRPr>
-            </a:pPr>
-          </a:p>
-          <a:p>
-            <a:pPr algn="l">
+                  <a:srgbClr val="191F1C"/>
+                </a:solidFill>
+                <a:latin typeface="Aptos"/>
+              </a:defRPr>
+            </a:pPr>
+            <a:r>
+              <a:t>•  base      control               200 ps      1.283</a:t>
+            </a:r>
+          </a:p>
+          <a:p>
+            <a:pPr>
+              <a:spcAft>
+                <a:spcPts val="300"/>
+              </a:spcAft>
               <a:defRPr sz="1700">
                 <a:solidFill>
-                  <a:srgbClr val="1E3027"/>
-                </a:solidFill>
-                <a:latin typeface="Consolas"/>
-              </a:defRPr>
-            </a:pPr>
-            <a:r>
-              <a:t>  pybis in ngspice            5.3371 ns</a:t>
-            </a:r>
-          </a:p>
-          <a:p>
-            <a:pPr algn="l">
+                  <a:srgbClr val="191F1C"/>
+                </a:solidFill>
+                <a:latin typeface="Aptos"/>
+              </a:defRPr>
+            </a:pPr>
+            <a:r>
+              <a:t>•  nomiller  Miller caps removed   208 ps      1.299</a:t>
+            </a:r>
+          </a:p>
+          <a:p>
+            <a:pPr>
+              <a:spcAft>
+                <a:spcPts val="300"/>
+              </a:spcAft>
               <a:defRPr sz="1700">
                 <a:solidFill>
-                  <a:srgbClr val="1E3027"/>
-                </a:solidFill>
-                <a:latin typeface="Consolas"/>
-              </a:defRPr>
-            </a:pPr>
-            <a:r>
-              <a:t>  pybis in HSPICE             5.3375 ns     engine  -0.5 ps</a:t>
-            </a:r>
-          </a:p>
-          <a:p>
-            <a:pPr algn="l">
+                  <a:srgbClr val="191F1C"/>
+                </a:solidFill>
+                <a:latin typeface="Aptos"/>
+              </a:defRPr>
+            </a:pPr>
+            <a:r>
+              <a:t>•  skewp     output PMOS halved    160 ps      1.589</a:t>
+            </a:r>
+          </a:p>
+          <a:p>
+            <a:pPr>
+              <a:spcAft>
+                <a:spcPts val="300"/>
+              </a:spcAft>
               <a:defRPr sz="1700">
                 <a:solidFill>
-                  <a:srgbClr val="1E3027"/>
-                </a:solidFill>
-                <a:latin typeface="Consolas"/>
-              </a:defRPr>
-            </a:pPr>
-            <a:r>
-              <a:t>  native IBIS in HSPICE       5.3319 ns     model   +5.6 ps</a:t>
+                  <a:srgbClr val="191F1C"/>
+                </a:solidFill>
+                <a:latin typeface="Aptos"/>
+              </a:defRPr>
+            </a:pPr>
+            <a:r>
+              <a:t>•  weak      both devices halved   152 ps      1.779</a:t>
             </a:r>
           </a:p>
         </p:txBody>
@@ -3769,8 +3804,8 @@
         </p:nvSpPr>
         <p:spPr>
           <a:xfrm>
-            <a:off x="640080" y="4297680"/>
-            <a:ext cx="10972800" cy="914400"/>
+            <a:off x="640080" y="4480560"/>
+            <a:ext cx="10972800" cy="1463040"/>
           </a:xfrm>
           <a:prstGeom prst="rect">
             <a:avLst/>
@@ -3792,62 +3827,11 @@
               </a:defRPr>
             </a:pPr>
             <a:r>
-              <a:t>The engine is not the source, provided ngspice is converged. At a 1 ps step it was an aliasing outlier that doubled the apparent lag.</a:t>
-            </a:r>
-          </a:p>
-        </p:txBody>
-      </p:sp>
-      <p:sp>
-        <p:nvSpPr>
-          <p:cNvPr id="7" name="Rectangle 6"/>
-          <p:cNvSpPr/>
-          <p:nvPr/>
-        </p:nvSpPr>
-        <p:spPr>
-          <a:xfrm>
-            <a:off x="384048" y="6062472"/>
-            <a:ext cx="11109960" cy="393192"/>
-          </a:xfrm>
-          <a:prstGeom prst="rect">
-            <a:avLst/>
-          </a:prstGeom>
-          <a:solidFill>
-            <a:srgbClr val="F1F8F2"/>
-          </a:solidFill>
-          <a:ln>
-            <a:solidFill>
-              <a:srgbClr val="F1F8F2"/>
-            </a:solidFill>
-          </a:ln>
-        </p:spPr>
-        <p:style>
-          <a:lnRef idx="1">
-            <a:schemeClr val="accent1"/>
-          </a:lnRef>
-          <a:fillRef idx="3">
-            <a:schemeClr val="accent1"/>
-          </a:fillRef>
-          <a:effectRef idx="2">
-            <a:schemeClr val="accent1"/>
-          </a:effectRef>
-          <a:fontRef idx="minor">
-            <a:schemeClr val="lt1"/>
-          </a:fontRef>
-        </p:style>
-        <p:txBody>
-          <a:bodyPr rtlCol="0" anchor="ctr"/>
-          <a:lstStyle/>
-          <a:p>
-            <a:pPr algn="ctr">
-              <a:defRPr sz="1400" b="1">
-                <a:solidFill>
-                  <a:srgbClr val="2B7A43"/>
-                </a:solidFill>
-                <a:latin typeface="Aptos"/>
-              </a:defRPr>
-            </a:pPr>
-            <a:r>
-              <a:t>Converged, the two engines agree to half a picosecond.</a:t>
+              <a:t>It follows C_comp × dV/dt against the device drive. For ex2 that is 82 mA of displacement current against a ~51 mA drive — it exceeds the device, so the solve has to push Ku above 1.</a:t>
+            </a:r>
+            <a:br/>
+            <a:r>
+              <a:t>Healthy baselines differ per silicon: inv_chain 1.03, io_buf 1.18, ex2 1.28. No absolute number works; it should be a within-buffer outlier test.</a:t>
             </a:r>
           </a:p>
         </p:txBody>
@@ -3894,7 +3878,7 @@
               </a:defRPr>
             </a:pPr>
             <a:r>
-              <a:t>What fixtures do to the extracted Ku/Kd</a:t>
+              <a:t>Nine new buffer variants, same stress axis</a:t>
             </a:r>
           </a:p>
         </p:txBody>
@@ -3930,7 +3914,7 @@
               </a:defRPr>
             </a:pPr>
             <a:r>
-              <a:t>METHOD</a:t>
+              <a:t>WHAT SHOULD CHANGE</a:t>
             </a:r>
           </a:p>
         </p:txBody>
@@ -3943,8 +3927,8 @@
         </p:nvSpPr>
         <p:spPr>
           <a:xfrm>
-            <a:off x="640080" y="1371600"/>
-            <a:ext cx="10972800" cy="2743200"/>
+            <a:off x="640080" y="1170432"/>
+            <a:ext cx="11064240" cy="1371600"/>
           </a:xfrm>
           <a:prstGeom prst="rect">
             <a:avLst/>
@@ -3959,7 +3943,7 @@
           <a:p>
             <a:pPr>
               <a:spcAft>
-                <a:spcPts val="700"/>
+                <a:spcPts val="300"/>
               </a:spcAft>
               <a:defRPr sz="1700">
                 <a:solidFill>
@@ -3969,13 +3953,13 @@
               </a:defRPr>
             </a:pPr>
             <a:r>
-              <a:t>•  The control reproduces the shipped solve to 2.4e-08, so the method is exact.</a:t>
+              <a:t>•  Slower predriver, halved output devices, skewed PMOS, open-drain.</a:t>
             </a:r>
           </a:p>
           <a:p>
             <a:pPr>
               <a:spcAft>
-                <a:spcPts val="700"/>
+                <a:spcPts val="300"/>
               </a:spcAft>
               <a:defRPr sz="1700">
                 <a:solidFill>
@@ -3985,83 +3969,31 @@
               </a:defRPr>
             </a:pPr>
             <a:r>
-              <a:t>•  In quiet regions Ku is load-independent to four decimals. It is a device property, not a fixture artifact.</a:t>
-            </a:r>
-          </a:p>
-          <a:p>
-            <a:pPr>
-              <a:spcAft>
-                <a:spcPts val="700"/>
-              </a:spcAft>
-              <a:defRPr sz="1700">
-                <a:solidFill>
-                  <a:srgbClr val="191F1C"/>
-                </a:solidFill>
-                <a:latin typeface="Aptos"/>
-              </a:defRPr>
-            </a:pPr>
-            <a:r>
-              <a:t>•  A resonant R+L+C fixture corrupts Ku for 1.14 ns, reaching 0.26 of error.</a:t>
-            </a:r>
-          </a:p>
-        </p:txBody>
-      </p:sp>
-      <p:sp>
-        <p:nvSpPr>
-          <p:cNvPr id="5" name="TextBox 4"/>
-          <p:cNvSpPr txBox="1"/>
-          <p:nvPr/>
-        </p:nvSpPr>
-        <p:spPr>
-          <a:xfrm>
-            <a:off x="640080" y="2926080"/>
-            <a:ext cx="10972800" cy="914400"/>
-          </a:xfrm>
-          <a:prstGeom prst="rect">
-            <a:avLst/>
-          </a:prstGeom>
-          <a:noFill/>
-        </p:spPr>
-        <p:txBody>
-          <a:bodyPr wrap="square" lIns="45720" rIns="45720" anchor="t">
-            <a:spAutoFit/>
-          </a:bodyPr>
-          <a:lstStyle/>
-          <a:p>
-            <a:pPr algn="l">
-              <a:defRPr sz="1700" b="0">
-                <a:solidFill>
-                  <a:srgbClr val="191F1C"/>
-                </a:solidFill>
-                <a:latin typeface="Aptos"/>
-              </a:defRPr>
-            </a:pPr>
-            <a:r>
-              <a:t>Added L and C are safe individually. The resonant combination has to be avoided when characterising.</a:t>
-            </a:r>
-          </a:p>
-        </p:txBody>
-      </p:sp>
-      <p:sp>
-        <p:nvSpPr>
-          <p:cNvPr id="6" name="Rectangle 5"/>
+              <a:t>•  Characterised and stressed exactly like the three base buffers.</a:t>
+            </a:r>
+          </a:p>
+        </p:txBody>
+      </p:sp>
+      <p:sp>
+        <p:nvSpPr>
+          <p:cNvPr id="5" name="Rectangle 4"/>
           <p:cNvSpPr/>
           <p:nvPr/>
         </p:nvSpPr>
         <p:spPr>
           <a:xfrm>
-            <a:off x="384048" y="6062472"/>
-            <a:ext cx="11109960" cy="393192"/>
+            <a:off x="513743" y="2057400"/>
+            <a:ext cx="5373312" cy="4398264"/>
           </a:xfrm>
           <a:prstGeom prst="rect">
             <a:avLst/>
           </a:prstGeom>
           <a:solidFill>
-            <a:srgbClr val="F1F8F2"/>
+            <a:srgbClr val="FFFFFF"/>
           </a:solidFill>
-          <a:ln>
+          <a:ln w="10160">
             <a:solidFill>
-              <a:srgbClr val="F1F8F2"/>
+              <a:srgbClr val="CBD0CC"/>
             </a:solidFill>
           </a:ln>
         </p:spPr>
@@ -4083,20 +4015,103 @@
           <a:bodyPr rtlCol="0" anchor="ctr"/>
           <a:lstStyle/>
           <a:p>
-            <a:pPr algn="ctr">
-              <a:defRPr sz="1400" b="1">
-                <a:solidFill>
-                  <a:srgbClr val="2B7A43"/>
-                </a:solidFill>
-                <a:latin typeface="Aptos"/>
-              </a:defRPr>
-            </a:pPr>
-            <a:r>
-              <a:t>The two-fixture extraction is trustworthy, as long as the fixture is not resonant.</a:t>
-            </a:r>
-          </a:p>
-        </p:txBody>
-      </p:sp>
+            <a:pPr algn="ctr"/>
+          </a:p>
+        </p:txBody>
+      </p:sp>
+      <p:pic>
+        <p:nvPicPr>
+          <p:cNvPr id="6" name="Picture 5" descr="variant_pad.png"/>
+          <p:cNvPicPr>
+            <a:picLocks noChangeAspect="1"/>
+          </p:cNvPicPr>
+          <p:nvPr/>
+        </p:nvPicPr>
+        <p:blipFill>
+          <a:blip r:embed="rId2"/>
+          <a:stretch>
+            <a:fillRect/>
+          </a:stretch>
+        </p:blipFill>
+        <p:spPr>
+          <a:xfrm>
+            <a:off x="541175" y="2084831"/>
+            <a:ext cx="5318448" cy="4343400"/>
+          </a:xfrm>
+          <a:prstGeom prst="rect">
+            <a:avLst/>
+          </a:prstGeom>
+        </p:spPr>
+      </p:pic>
+      <p:sp>
+        <p:nvSpPr>
+          <p:cNvPr id="7" name="Rectangle 6"/>
+          <p:cNvSpPr/>
+          <p:nvPr/>
+        </p:nvSpPr>
+        <p:spPr>
+          <a:xfrm>
+            <a:off x="6274463" y="2057400"/>
+            <a:ext cx="5373312" cy="4398264"/>
+          </a:xfrm>
+          <a:prstGeom prst="rect">
+            <a:avLst/>
+          </a:prstGeom>
+          <a:solidFill>
+            <a:srgbClr val="FFFFFF"/>
+          </a:solidFill>
+          <a:ln w="10160">
+            <a:solidFill>
+              <a:srgbClr val="CBD0CC"/>
+            </a:solidFill>
+          </a:ln>
+        </p:spPr>
+        <p:style>
+          <a:lnRef idx="1">
+            <a:schemeClr val="accent1"/>
+          </a:lnRef>
+          <a:fillRef idx="3">
+            <a:schemeClr val="accent1"/>
+          </a:fillRef>
+          <a:effectRef idx="2">
+            <a:schemeClr val="accent1"/>
+          </a:effectRef>
+          <a:fontRef idx="minor">
+            <a:schemeClr val="lt1"/>
+          </a:fontRef>
+        </p:style>
+        <p:txBody>
+          <a:bodyPr rtlCol="0" anchor="ctr"/>
+          <a:lstStyle/>
+          <a:p>
+            <a:pPr algn="ctr"/>
+          </a:p>
+        </p:txBody>
+      </p:sp>
+      <p:pic>
+        <p:nvPicPr>
+          <p:cNvPr id="8" name="Picture 7" descr="variant_kukd.png"/>
+          <p:cNvPicPr>
+            <a:picLocks noChangeAspect="1"/>
+          </p:cNvPicPr>
+          <p:nvPr/>
+        </p:nvPicPr>
+        <p:blipFill>
+          <a:blip r:embed="rId3"/>
+          <a:stretch>
+            <a:fillRect/>
+          </a:stretch>
+        </p:blipFill>
+        <p:spPr>
+          <a:xfrm>
+            <a:off x="6301895" y="2084831"/>
+            <a:ext cx="5318448" cy="4343400"/>
+          </a:xfrm>
+          <a:prstGeom prst="rect">
+            <a:avLst/>
+          </a:prstGeom>
+        </p:spPr>
+      </p:pic>
     </p:spTree>
   </p:cSld>
   <p:clrMapOvr>
@@ -4139,7 +4154,7 @@
               </a:defRPr>
             </a:pPr>
             <a:r>
-              <a:t>The 1.25 max|Ku| cap rejects good models</a:t>
+              <a:t>Where this leaves us</a:t>
             </a:r>
           </a:p>
         </p:txBody>
@@ -4175,192 +4190,21 @@
               </a:defRPr>
             </a:pPr>
             <a:r>
-              <a:t>WHAT SHOULD CHANGE</a:t>
-            </a:r>
-          </a:p>
-        </p:txBody>
-      </p:sp>
-      <p:sp>
-        <p:nvSpPr>
-          <p:cNvPr id="4" name="Rectangle 3"/>
-          <p:cNvSpPr/>
-          <p:nvPr/>
-        </p:nvSpPr>
-        <p:spPr>
-          <a:xfrm>
-            <a:off x="475488" y="1207008"/>
-            <a:ext cx="11210544" cy="4535423"/>
-          </a:xfrm>
-          <a:prstGeom prst="rect">
-            <a:avLst/>
-          </a:prstGeom>
-          <a:solidFill>
-            <a:srgbClr val="FFFFFF"/>
-          </a:solidFill>
-          <a:ln w="10160">
-            <a:solidFill>
-              <a:srgbClr val="CBD0CC"/>
-            </a:solidFill>
-          </a:ln>
-        </p:spPr>
-        <p:style>
-          <a:lnRef idx="1">
-            <a:schemeClr val="accent1"/>
-          </a:lnRef>
-          <a:fillRef idx="3">
-            <a:schemeClr val="accent1"/>
-          </a:fillRef>
-          <a:effectRef idx="2">
-            <a:schemeClr val="accent1"/>
-          </a:effectRef>
-          <a:fontRef idx="minor">
-            <a:schemeClr val="lt1"/>
-          </a:fontRef>
-        </p:style>
-        <p:txBody>
-          <a:bodyPr rtlCol="0" anchor="ctr"/>
-          <a:lstStyle/>
-          <a:p>
-            <a:pPr algn="ctr"/>
-          </a:p>
-        </p:txBody>
-      </p:sp>
-      <p:pic>
-        <p:nvPicPr>
-          <p:cNvPr id="5" name="Picture 4" descr="ku_cap.png"/>
-          <p:cNvPicPr>
-            <a:picLocks noChangeAspect="1"/>
-          </p:cNvPicPr>
-          <p:nvPr/>
-        </p:nvPicPr>
-        <p:blipFill>
-          <a:blip r:embed="rId2"/>
-          <a:stretch>
-            <a:fillRect/>
-          </a:stretch>
-        </p:blipFill>
-        <p:spPr>
-          <a:xfrm>
-            <a:off x="502920" y="1234440"/>
-            <a:ext cx="11155680" cy="4480559"/>
-          </a:xfrm>
-          <a:prstGeom prst="rect">
-            <a:avLst/>
-          </a:prstGeom>
-        </p:spPr>
-      </p:pic>
-      <p:sp>
-        <p:nvSpPr>
-          <p:cNvPr id="6" name="Rectangle 5"/>
-          <p:cNvSpPr/>
-          <p:nvPr/>
-        </p:nvSpPr>
-        <p:spPr>
-          <a:xfrm>
-            <a:off x="384048" y="6062472"/>
-            <a:ext cx="11109960" cy="393192"/>
-          </a:xfrm>
-          <a:prstGeom prst="rect">
-            <a:avLst/>
-          </a:prstGeom>
-          <a:solidFill>
-            <a:srgbClr val="F1F8F2"/>
-          </a:solidFill>
-          <a:ln>
-            <a:solidFill>
-              <a:srgbClr val="F1F8F2"/>
-            </a:solidFill>
-          </a:ln>
-        </p:spPr>
-        <p:style>
-          <a:lnRef idx="1">
-            <a:schemeClr val="accent1"/>
-          </a:lnRef>
-          <a:fillRef idx="3">
-            <a:schemeClr val="accent1"/>
-          </a:fillRef>
-          <a:effectRef idx="2">
-            <a:schemeClr val="accent1"/>
-          </a:effectRef>
-          <a:fontRef idx="minor">
-            <a:schemeClr val="lt1"/>
-          </a:fontRef>
-        </p:style>
-        <p:txBody>
-          <a:bodyPr rtlCol="0" anchor="ctr"/>
-          <a:lstStyle/>
-          <a:p>
-            <a:pPr algn="ctr">
-              <a:defRPr sz="1400" b="1">
-                <a:solidFill>
-                  <a:srgbClr val="2B7A43"/>
-                </a:solidFill>
-                <a:latin typeface="Aptos"/>
-              </a:defRPr>
-            </a:pPr>
-            <a:r>
-              <a:t>A high max|Ku| is a real signature of a large die capacitance driven fast, not a corrupted extraction.</a:t>
-            </a:r>
-          </a:p>
-        </p:txBody>
-      </p:sp>
-    </p:spTree>
-  </p:cSld>
-  <p:clrMapOvr>
-    <a:masterClrMapping/>
-  </p:clrMapOvr>
-</p:sld>
-</file>
-
-<file path=ppt/slides/slide15.xml><?xml version="1.0" encoding="utf-8"?>
-<p:sld xmlns:a="http://schemas.openxmlformats.org/drawingml/2006/main" xmlns:p="http://schemas.openxmlformats.org/presentationml/2006/main" xmlns:r="http://schemas.openxmlformats.org/officeDocument/2006/relationships">
-  <p:cSld>
-    <p:spTree>
-      <p:nvGrpSpPr>
-        <p:cNvPr id="1" name=""/>
-        <p:cNvGrpSpPr/>
-        <p:nvPr/>
-      </p:nvGrpSpPr>
-      <p:grpSpPr/>
-      <p:sp>
-        <p:nvSpPr>
-          <p:cNvPr id="2" name="Title 1"/>
-          <p:cNvSpPr>
-            <a:spLocks noGrp="1"/>
-          </p:cNvSpPr>
-          <p:nvPr>
-            <p:ph type="title"/>
-          </p:nvPr>
-        </p:nvSpPr>
-        <p:spPr/>
-        <p:txBody>
-          <a:bodyPr/>
-          <a:lstStyle/>
-          <a:p>
-            <a:pPr algn="l">
-              <a:defRPr sz="2700" b="0">
-                <a:solidFill>
-                  <a:srgbClr val="000000"/>
-                </a:solidFill>
-                <a:latin typeface="Times New Roman"/>
-              </a:defRPr>
-            </a:pPr>
-            <a:r>
-              <a:t>New buffers, and what they are for</a:t>
-            </a:r>
-          </a:p>
-        </p:txBody>
-      </p:sp>
-      <p:sp>
-        <p:nvSpPr>
-          <p:cNvPr id="3" name="TextBox 2"/>
+              <a:t>SUMMARY</a:t>
+            </a:r>
+          </a:p>
+        </p:txBody>
+      </p:sp>
+      <p:sp>
+        <p:nvSpPr>
+          <p:cNvPr id="4" name="TextBox 3"/>
           <p:cNvSpPr txBox="1"/>
           <p:nvPr/>
         </p:nvSpPr>
         <p:spPr>
           <a:xfrm>
-            <a:off x="9372600" y="109728"/>
-            <a:ext cx="2148840" cy="228600"/>
+            <a:off x="640080" y="1188720"/>
+            <a:ext cx="10972800" cy="457200"/>
           </a:xfrm>
           <a:prstGeom prst="rect">
             <a:avLst/>
@@ -4373,30 +4217,30 @@
           </a:bodyPr>
           <a:lstStyle/>
           <a:p>
-            <a:pPr algn="r">
-              <a:defRPr sz="950" b="1">
-                <a:solidFill>
-                  <a:srgbClr val="666C68"/>
+            <a:pPr algn="l">
+              <a:defRPr sz="1700" b="0">
+                <a:solidFill>
+                  <a:srgbClr val="191F1C"/>
                 </a:solidFill>
                 <a:latin typeface="Aptos"/>
               </a:defRPr>
             </a:pPr>
             <a:r>
-              <a:t>WHAT SHOULD CHANGE</a:t>
-            </a:r>
-          </a:p>
-        </p:txBody>
-      </p:sp>
-      <p:sp>
-        <p:nvSpPr>
-          <p:cNvPr id="4" name="TextBox 3"/>
+              <a:t>Settled:</a:t>
+            </a:r>
+          </a:p>
+        </p:txBody>
+      </p:sp>
+      <p:sp>
+        <p:nvSpPr>
+          <p:cNvPr id="5" name="TextBox 4"/>
           <p:cNvSpPr txBox="1"/>
           <p:nvPr/>
         </p:nvSpPr>
         <p:spPr>
           <a:xfrm>
-            <a:off x="640080" y="1280160"/>
-            <a:ext cx="10972800" cy="2560320"/>
+            <a:off x="640080" y="1737360"/>
+            <a:ext cx="11064240" cy="2743200"/>
           </a:xfrm>
           <a:prstGeom prst="rect">
             <a:avLst/>
@@ -4411,7 +4255,7 @@
           <a:p>
             <a:pPr>
               <a:spcAft>
-                <a:spcPts val="700"/>
+                <a:spcPts val="300"/>
               </a:spcAft>
               <a:defRPr sz="1700">
                 <a:solidFill>
@@ -4421,13 +4265,13 @@
               </a:defRPr>
             </a:pPr>
             <a:r>
-              <a:t>•  Nine variants of inv_chain and ex2 built in HSPICE with the real transistor library: slower predriver, halved output devices, skewed PMOS, Miller caps removed, plus an open-drain build.</a:t>
+              <a:t>•  C_comp is handled correctly</a:t>
             </a:r>
           </a:p>
           <a:p>
             <a:pPr>
               <a:spcAft>
-                <a:spcPts val="700"/>
+                <a:spcPts val="300"/>
               </a:spcAft>
               <a:defRPr sz="1700">
                 <a:solidFill>
@@ -4437,13 +4281,13 @@
               </a:defRPr>
             </a:pPr>
             <a:r>
-              <a:t>•  The point is to test whether what we learned on three buffers holds across different silicon.</a:t>
+              <a:t>•  the SPICE engine is not a confounder</a:t>
             </a:r>
           </a:p>
           <a:p>
             <a:pPr>
               <a:spcAft>
-                <a:spcPts val="700"/>
+                <a:spcPts val="300"/>
               </a:spcAft>
               <a:defRPr sz="1700">
                 <a:solidFill>
@@ -4453,21 +4297,37 @@
               </a:defRPr>
             </a:pPr>
             <a:r>
-              <a:t>•  Same characterisation, same stress axis, so the comparison is like for like.</a:t>
-            </a:r>
-          </a:p>
-        </p:txBody>
-      </p:sp>
-      <p:sp>
-        <p:nvSpPr>
-          <p:cNvPr id="5" name="TextBox 4"/>
+              <a:t>•  our model reproduces its own golden waveforms</a:t>
+            </a:r>
+          </a:p>
+          <a:p>
+            <a:pPr>
+              <a:spcAft>
+                <a:spcPts val="300"/>
+              </a:spcAft>
+              <a:defRPr sz="1700">
+                <a:solidFill>
+                  <a:srgbClr val="191F1C"/>
+                </a:solidFill>
+                <a:latin typeface="Aptos"/>
+              </a:defRPr>
+            </a:pPr>
+            <a:r>
+              <a:t>•  delay_cmd removes the settled offset</a:t>
+            </a:r>
+          </a:p>
+        </p:txBody>
+      </p:sp>
+      <p:sp>
+        <p:nvSpPr>
+          <p:cNvPr id="6" name="TextBox 5"/>
           <p:cNvSpPr txBox="1"/>
           <p:nvPr/>
         </p:nvSpPr>
         <p:spPr>
           <a:xfrm>
-            <a:off x="640080" y="4114800"/>
-            <a:ext cx="10972800" cy="914400"/>
+            <a:off x="640080" y="3840480"/>
+            <a:ext cx="10972800" cy="457200"/>
           </a:xfrm>
           <a:prstGeom prst="rect">
             <a:avLst/>
@@ -4489,366 +4349,21 @@
               </a:defRPr>
             </a:pPr>
             <a:r>
-              <a:t>Running now: the same 90-50% stress axis on all nine, with Ku and Kd solved from the transistor for every case.</a:t>
-            </a:r>
-          </a:p>
-        </p:txBody>
-      </p:sp>
-      <p:sp>
-        <p:nvSpPr>
-          <p:cNvPr id="6" name="Rectangle 5"/>
-          <p:cNvSpPr/>
-          <p:nvPr/>
-        </p:nvSpPr>
-        <p:spPr>
-          <a:xfrm>
-            <a:off x="384048" y="6062472"/>
-            <a:ext cx="11109960" cy="393192"/>
-          </a:xfrm>
-          <a:prstGeom prst="rect">
-            <a:avLst/>
-          </a:prstGeom>
-          <a:solidFill>
-            <a:srgbClr val="F1F8F2"/>
-          </a:solidFill>
-          <a:ln>
-            <a:solidFill>
-              <a:srgbClr val="F1F8F2"/>
-            </a:solidFill>
-          </a:ln>
-        </p:spPr>
-        <p:style>
-          <a:lnRef idx="1">
-            <a:schemeClr val="accent1"/>
-          </a:lnRef>
-          <a:fillRef idx="3">
-            <a:schemeClr val="accent1"/>
-          </a:fillRef>
-          <a:effectRef idx="2">
-            <a:schemeClr val="accent1"/>
-          </a:effectRef>
-          <a:fontRef idx="minor">
-            <a:schemeClr val="lt1"/>
-          </a:fontRef>
-        </p:style>
-        <p:txBody>
-          <a:bodyPr rtlCol="0" anchor="ctr"/>
-          <a:lstStyle/>
-          <a:p>
-            <a:pPr algn="ctr">
-              <a:defRPr sz="1400" b="1">
-                <a:solidFill>
-                  <a:srgbClr val="2B7A43"/>
-                </a:solidFill>
-                <a:latin typeface="Aptos"/>
-              </a:defRPr>
-            </a:pPr>
-            <a:r>
-              <a:t>Ku and Kd show what the pad trace hides.</a:t>
-            </a:r>
-          </a:p>
-        </p:txBody>
-      </p:sp>
-    </p:spTree>
-  </p:cSld>
-  <p:clrMapOvr>
-    <a:masterClrMapping/>
-  </p:clrMapOvr>
-</p:sld>
-</file>
-
-<file path=ppt/slides/slide16.xml><?xml version="1.0" encoding="utf-8"?>
-<p:sld xmlns:a="http://schemas.openxmlformats.org/drawingml/2006/main" xmlns:p="http://schemas.openxmlformats.org/presentationml/2006/main" xmlns:r="http://schemas.openxmlformats.org/officeDocument/2006/relationships">
-  <p:cSld>
-    <p:spTree>
-      <p:nvGrpSpPr>
-        <p:cNvPr id="1" name=""/>
-        <p:cNvGrpSpPr/>
-        <p:nvPr/>
-      </p:nvGrpSpPr>
-      <p:grpSpPr/>
-      <p:sp>
-        <p:nvSpPr>
-          <p:cNvPr id="2" name="Title 1"/>
-          <p:cNvSpPr>
-            <a:spLocks noGrp="1"/>
-          </p:cNvSpPr>
-          <p:nvPr>
-            <p:ph type="title"/>
-          </p:nvPr>
-        </p:nvSpPr>
-        <p:spPr/>
-        <p:txBody>
-          <a:bodyPr/>
-          <a:lstStyle/>
-          <a:p>
-            <a:pPr algn="l">
-              <a:defRPr sz="2700" b="0">
-                <a:solidFill>
-                  <a:srgbClr val="000000"/>
-                </a:solidFill>
-                <a:latin typeface="Times New Roman"/>
-              </a:defRPr>
-            </a:pPr>
-            <a:r>
-              <a:t>The coefficients under stress</a:t>
-            </a:r>
-          </a:p>
-        </p:txBody>
-      </p:sp>
-      <p:sp>
-        <p:nvSpPr>
-          <p:cNvPr id="3" name="TextBox 2"/>
+              <a:t>Open:</a:t>
+            </a:r>
+          </a:p>
+        </p:txBody>
+      </p:sp>
+      <p:sp>
+        <p:nvSpPr>
+          <p:cNvPr id="7" name="TextBox 6"/>
           <p:cNvSpPr txBox="1"/>
           <p:nvPr/>
         </p:nvSpPr>
         <p:spPr>
           <a:xfrm>
-            <a:off x="9372600" y="109728"/>
-            <a:ext cx="2148840" cy="228600"/>
-          </a:xfrm>
-          <a:prstGeom prst="rect">
-            <a:avLst/>
-          </a:prstGeom>
-          <a:noFill/>
-        </p:spPr>
-        <p:txBody>
-          <a:bodyPr wrap="square" lIns="45720" rIns="45720" anchor="t">
-            <a:spAutoFit/>
-          </a:bodyPr>
-          <a:lstStyle/>
-          <a:p>
-            <a:pPr algn="r">
-              <a:defRPr sz="950" b="1">
-                <a:solidFill>
-                  <a:srgbClr val="666C68"/>
-                </a:solidFill>
-                <a:latin typeface="Aptos"/>
-              </a:defRPr>
-            </a:pPr>
-            <a:r>
-              <a:t>WHAT SHOULD CHANGE</a:t>
-            </a:r>
-          </a:p>
-        </p:txBody>
-      </p:sp>
-      <p:sp>
-        <p:nvSpPr>
-          <p:cNvPr id="4" name="Rectangle 3"/>
-          <p:cNvSpPr/>
-          <p:nvPr/>
-        </p:nvSpPr>
-        <p:spPr>
-          <a:xfrm>
-            <a:off x="475488" y="1143000"/>
-            <a:ext cx="11210544" cy="4809743"/>
-          </a:xfrm>
-          <a:prstGeom prst="rect">
-            <a:avLst/>
-          </a:prstGeom>
-          <a:solidFill>
-            <a:srgbClr val="FFFFFF"/>
-          </a:solidFill>
-          <a:ln w="10160">
-            <a:solidFill>
-              <a:srgbClr val="CBD0CC"/>
-            </a:solidFill>
-          </a:ln>
-        </p:spPr>
-        <p:style>
-          <a:lnRef idx="1">
-            <a:schemeClr val="accent1"/>
-          </a:lnRef>
-          <a:fillRef idx="3">
-            <a:schemeClr val="accent1"/>
-          </a:fillRef>
-          <a:effectRef idx="2">
-            <a:schemeClr val="accent1"/>
-          </a:effectRef>
-          <a:fontRef idx="minor">
-            <a:schemeClr val="lt1"/>
-          </a:fontRef>
-        </p:style>
-        <p:txBody>
-          <a:bodyPr rtlCol="0" anchor="ctr"/>
-          <a:lstStyle/>
-          <a:p>
-            <a:pPr algn="ctr"/>
-          </a:p>
-        </p:txBody>
-      </p:sp>
-      <p:pic>
-        <p:nvPicPr>
-          <p:cNvPr id="5" name="Picture 4" descr="variant_kukd.png"/>
-          <p:cNvPicPr>
-            <a:picLocks noChangeAspect="1"/>
-          </p:cNvPicPr>
-          <p:nvPr/>
-        </p:nvPicPr>
-        <p:blipFill>
-          <a:blip r:embed="rId2"/>
-          <a:stretch>
-            <a:fillRect/>
-          </a:stretch>
-        </p:blipFill>
-        <p:spPr>
-          <a:xfrm>
-            <a:off x="502920" y="1170432"/>
-            <a:ext cx="11155680" cy="4754879"/>
-          </a:xfrm>
-          <a:prstGeom prst="rect">
-            <a:avLst/>
-          </a:prstGeom>
-        </p:spPr>
-      </p:pic>
-      <p:sp>
-        <p:nvSpPr>
-          <p:cNvPr id="6" name="Rectangle 5"/>
-          <p:cNvSpPr/>
-          <p:nvPr/>
-        </p:nvSpPr>
-        <p:spPr>
-          <a:xfrm>
-            <a:off x="384048" y="6062472"/>
-            <a:ext cx="11109960" cy="393192"/>
-          </a:xfrm>
-          <a:prstGeom prst="rect">
-            <a:avLst/>
-          </a:prstGeom>
-          <a:solidFill>
-            <a:srgbClr val="F1F8F2"/>
-          </a:solidFill>
-          <a:ln>
-            <a:solidFill>
-              <a:srgbClr val="F1F8F2"/>
-            </a:solidFill>
-          </a:ln>
-        </p:spPr>
-        <p:style>
-          <a:lnRef idx="1">
-            <a:schemeClr val="accent1"/>
-          </a:lnRef>
-          <a:fillRef idx="3">
-            <a:schemeClr val="accent1"/>
-          </a:fillRef>
-          <a:effectRef idx="2">
-            <a:schemeClr val="accent1"/>
-          </a:effectRef>
-          <a:fontRef idx="minor">
-            <a:schemeClr val="lt1"/>
-          </a:fontRef>
-        </p:style>
-        <p:txBody>
-          <a:bodyPr rtlCol="0" anchor="ctr"/>
-          <a:lstStyle/>
-          <a:p>
-            <a:pPr algn="ctr">
-              <a:defRPr sz="1400" b="1">
-                <a:solidFill>
-                  <a:srgbClr val="2B7A43"/>
-                </a:solidFill>
-                <a:latin typeface="Aptos"/>
-              </a:defRPr>
-            </a:pPr>
-            <a:r>
-              <a:t>The gate-state build starts moving before the transistor does. Visible in Ku, invisible in the pad.</a:t>
-            </a:r>
-          </a:p>
-        </p:txBody>
-      </p:sp>
-    </p:spTree>
-  </p:cSld>
-  <p:clrMapOvr>
-    <a:masterClrMapping/>
-  </p:clrMapOvr>
-</p:sld>
-</file>
-
-<file path=ppt/slides/slide17.xml><?xml version="1.0" encoding="utf-8"?>
-<p:sld xmlns:a="http://schemas.openxmlformats.org/drawingml/2006/main" xmlns:p="http://schemas.openxmlformats.org/presentationml/2006/main" xmlns:r="http://schemas.openxmlformats.org/officeDocument/2006/relationships">
-  <p:cSld>
-    <p:spTree>
-      <p:nvGrpSpPr>
-        <p:cNvPr id="1" name=""/>
-        <p:cNvGrpSpPr/>
-        <p:nvPr/>
-      </p:nvGrpSpPr>
-      <p:grpSpPr/>
-      <p:sp>
-        <p:nvSpPr>
-          <p:cNvPr id="2" name="Title 1"/>
-          <p:cNvSpPr>
-            <a:spLocks noGrp="1"/>
-          </p:cNvSpPr>
-          <p:nvPr>
-            <p:ph type="title"/>
-          </p:nvPr>
-        </p:nvSpPr>
-        <p:spPr/>
-        <p:txBody>
-          <a:bodyPr/>
-          <a:lstStyle/>
-          <a:p>
-            <a:pPr algn="l">
-              <a:defRPr sz="2700" b="0">
-                <a:solidFill>
-                  <a:srgbClr val="000000"/>
-                </a:solidFill>
-                <a:latin typeface="Times New Roman"/>
-              </a:defRPr>
-            </a:pPr>
-            <a:r>
-              <a:t>Where this leaves us</a:t>
-            </a:r>
-          </a:p>
-        </p:txBody>
-      </p:sp>
-      <p:sp>
-        <p:nvSpPr>
-          <p:cNvPr id="3" name="TextBox 2"/>
-          <p:cNvSpPr txBox="1"/>
-          <p:nvPr/>
-        </p:nvSpPr>
-        <p:spPr>
-          <a:xfrm>
-            <a:off x="9372600" y="109728"/>
-            <a:ext cx="2148840" cy="228600"/>
-          </a:xfrm>
-          <a:prstGeom prst="rect">
-            <a:avLst/>
-          </a:prstGeom>
-          <a:noFill/>
-        </p:spPr>
-        <p:txBody>
-          <a:bodyPr wrap="square" lIns="45720" rIns="45720" anchor="t">
-            <a:spAutoFit/>
-          </a:bodyPr>
-          <a:lstStyle/>
-          <a:p>
-            <a:pPr algn="r">
-              <a:defRPr sz="950" b="1">
-                <a:solidFill>
-                  <a:srgbClr val="666C68"/>
-                </a:solidFill>
-                <a:latin typeface="Aptos"/>
-              </a:defRPr>
-            </a:pPr>
-            <a:r>
-              <a:t>SUMMARY</a:t>
-            </a:r>
-          </a:p>
-        </p:txBody>
-      </p:sp>
-      <p:sp>
-        <p:nvSpPr>
-          <p:cNvPr id="4" name="TextBox 3"/>
-          <p:cNvSpPr txBox="1"/>
-          <p:nvPr/>
-        </p:nvSpPr>
-        <p:spPr>
-          <a:xfrm>
-            <a:off x="640080" y="1280160"/>
-            <a:ext cx="10972800" cy="2743200"/>
+            <a:off x="640080" y="4389120"/>
+            <a:ext cx="11064240" cy="1371600"/>
           </a:xfrm>
           <a:prstGeom prst="rect">
             <a:avLst/>
@@ -4863,7 +4378,7 @@
           <a:p>
             <a:pPr>
               <a:spcAft>
-                <a:spcPts val="700"/>
+                <a:spcPts val="300"/>
               </a:spcAft>
               <a:defRPr sz="1700">
                 <a:solidFill>
@@ -4873,13 +4388,13 @@
               </a:defRPr>
             </a:pPr>
             <a:r>
-              <a:t>•  Settled: C_comp is right, the engine is not a confounder, pybis reproduces its own golden waveforms, and delay_cmd fixes the offset.</a:t>
+              <a:t>•  the timing shift has no candidate mechanism, and grows with truncation</a:t>
             </a:r>
           </a:p>
           <a:p>
             <a:pPr>
               <a:spcAft>
-                <a:spcPts val="700"/>
+                <a:spcPts val="300"/>
               </a:spcAft>
               <a:defRPr sz="1700">
                 <a:solidFill>
@@ -4889,114 +4404,7 @@
               </a:defRPr>
             </a:pPr>
             <a:r>
-              <a:t>•  Open: the timing shift has no candidate mechanism, and it grows with truncation on every buffer tried.</a:t>
-            </a:r>
-          </a:p>
-          <a:p>
-            <a:pPr>
-              <a:spcAft>
-                <a:spcPts val="700"/>
-              </a:spcAft>
-              <a:defRPr sz="1700">
-                <a:solidFill>
-                  <a:srgbClr val="191F1C"/>
-                </a:solidFill>
-                <a:latin typeface="Aptos"/>
-              </a:defRPr>
-            </a:pPr>
-            <a:r>
-              <a:t>•  Open: the 1.25 max|Ku| cap needs replacing before it rejects more good models.</a:t>
-            </a:r>
-          </a:p>
-        </p:txBody>
-      </p:sp>
-      <p:sp>
-        <p:nvSpPr>
-          <p:cNvPr id="5" name="TextBox 4"/>
-          <p:cNvSpPr txBox="1"/>
-          <p:nvPr/>
-        </p:nvSpPr>
-        <p:spPr>
-          <a:xfrm>
-            <a:off x="640080" y="3200400"/>
-            <a:ext cx="10972800" cy="1280160"/>
-          </a:xfrm>
-          <a:prstGeom prst="rect">
-            <a:avLst/>
-          </a:prstGeom>
-          <a:noFill/>
-        </p:spPr>
-        <p:txBody>
-          <a:bodyPr wrap="square" lIns="45720" rIns="45720" anchor="t">
-            <a:spAutoFit/>
-          </a:bodyPr>
-          <a:lstStyle/>
-          <a:p>
-            <a:pPr algn="l">
-              <a:defRPr sz="1700" b="0">
-                <a:solidFill>
-                  <a:srgbClr val="191F1C"/>
-                </a:solidFill>
-                <a:latin typeface="Aptos"/>
-              </a:defRPr>
-            </a:pPr>
-            <a:r>
-              <a:t>Two rules worth not re-learning: any bench for this model must start with a real edge, never a held level. And ngspice must be converged before drawing any conclusion from it.</a:t>
-            </a:r>
-          </a:p>
-        </p:txBody>
-      </p:sp>
-      <p:sp>
-        <p:nvSpPr>
-          <p:cNvPr id="6" name="Rectangle 5"/>
-          <p:cNvSpPr/>
-          <p:nvPr/>
-        </p:nvSpPr>
-        <p:spPr>
-          <a:xfrm>
-            <a:off x="384048" y="6062472"/>
-            <a:ext cx="11109960" cy="393192"/>
-          </a:xfrm>
-          <a:prstGeom prst="rect">
-            <a:avLst/>
-          </a:prstGeom>
-          <a:solidFill>
-            <a:srgbClr val="F1F8F2"/>
-          </a:solidFill>
-          <a:ln>
-            <a:solidFill>
-              <a:srgbClr val="F1F8F2"/>
-            </a:solidFill>
-          </a:ln>
-        </p:spPr>
-        <p:style>
-          <a:lnRef idx="1">
-            <a:schemeClr val="accent1"/>
-          </a:lnRef>
-          <a:fillRef idx="3">
-            <a:schemeClr val="accent1"/>
-          </a:fillRef>
-          <a:effectRef idx="2">
-            <a:schemeClr val="accent1"/>
-          </a:effectRef>
-          <a:fontRef idx="minor">
-            <a:schemeClr val="lt1"/>
-          </a:fontRef>
-        </p:style>
-        <p:txBody>
-          <a:bodyPr rtlCol="0" anchor="ctr"/>
-          <a:lstStyle/>
-          <a:p>
-            <a:pPr algn="ctr">
-              <a:defRPr sz="1400" b="1">
-                <a:solidFill>
-                  <a:srgbClr val="2B7A43"/>
-                </a:solidFill>
-                <a:latin typeface="Aptos"/>
-              </a:defRPr>
-            </a:pPr>
-            <a:r>
-              <a:t>The offset is solved. The timing shift is the open one, and it is where the nine variants will land.</a:t>
+              <a:t>•  the 1.25 max|Ku| cap needs replacing with a within-buffer outlier test</a:t>
             </a:r>
           </a:p>
         </p:txBody>
@@ -5043,7 +4451,7 @@
               </a:defRPr>
             </a:pPr>
             <a:r>
-              <a:t>What we are trying to do</a:t>
+              <a:t>What we are comparing</a:t>
             </a:r>
           </a:p>
         </p:txBody>
@@ -5092,8 +4500,8 @@
         </p:nvSpPr>
         <p:spPr>
           <a:xfrm>
-            <a:off x="640080" y="1280160"/>
-            <a:ext cx="5394960" cy="2011680"/>
+            <a:off x="640080" y="1170432"/>
+            <a:ext cx="11064240" cy="2057400"/>
           </a:xfrm>
           <a:prstGeom prst="rect">
             <a:avLst/>
@@ -5108,7 +4516,7 @@
           <a:p>
             <a:pPr>
               <a:spcAft>
-                <a:spcPts val="700"/>
+                <a:spcPts val="300"/>
               </a:spcAft>
               <a:defRPr sz="1700">
                 <a:solidFill>
@@ -5118,13 +4526,13 @@
               </a:defRPr>
             </a:pPr>
             <a:r>
-              <a:t>•  The transistor netlist in HSPICE is ground truth.</a:t>
+              <a:t>•  HSPICE transistor — ground truth</a:t>
             </a:r>
           </a:p>
           <a:p>
             <a:pPr>
               <a:spcAft>
-                <a:spcPts val="700"/>
+                <a:spcPts val="300"/>
               </a:spcAft>
               <a:defRPr sz="1700">
                 <a:solidFill>
@@ -5134,13 +4542,13 @@
               </a:defRPr>
             </a:pPr>
             <a:r>
-              <a:t>•  Native IBIS is the bar to beat, not the target.</a:t>
+              <a:t>•  HSPICE native IBIS — the bar to beat, not the target</a:t>
             </a:r>
           </a:p>
           <a:p>
             <a:pPr>
               <a:spcAft>
-                <a:spcPts val="700"/>
+                <a:spcPts val="300"/>
               </a:spcAft>
               <a:defRPr sz="1700">
                 <a:solidFill>
@@ -5150,7 +4558,7 @@
               </a:defRPr>
             </a:pPr>
             <a:r>
-              <a:t>•  Everything here is measured against the transistor.</a:t>
+              <a:t>•  Our IBIS model in ngspice — measured against the transistor</a:t>
             </a:r>
           </a:p>
         </p:txBody>
@@ -5163,8 +4571,8 @@
         </p:nvSpPr>
         <p:spPr>
           <a:xfrm>
-            <a:off x="640080" y="3017520"/>
-            <a:ext cx="10972800" cy="1097280"/>
+            <a:off x="640080" y="2651760"/>
+            <a:ext cx="10972800" cy="457200"/>
           </a:xfrm>
           <a:prstGeom prst="rect">
             <a:avLst/>
@@ -5186,62 +4594,114 @@
               </a:defRPr>
             </a:pPr>
             <a:r>
-              <a:t>Two things move in any comparison — the IBIS implementation and the SPICE engine. We separated them, and the engine is not the source.</a:t>
-            </a:r>
-          </a:p>
-        </p:txBody>
-      </p:sp>
-      <p:sp>
-        <p:nvSpPr>
-          <p:cNvPr id="6" name="Rectangle 5"/>
-          <p:cNvSpPr/>
+              <a:t>Falling 50% crossing on io_buf at full swing, later than the transistor:</a:t>
+            </a:r>
+          </a:p>
+        </p:txBody>
+      </p:sp>
+      <p:sp>
+        <p:nvSpPr>
+          <p:cNvPr id="6" name="TextBox 5"/>
+          <p:cNvSpPr txBox="1"/>
           <p:nvPr/>
         </p:nvSpPr>
         <p:spPr>
           <a:xfrm>
-            <a:off x="384048" y="6062472"/>
-            <a:ext cx="11109960" cy="393192"/>
-          </a:xfrm>
-          <a:prstGeom prst="rect">
-            <a:avLst/>
-          </a:prstGeom>
-          <a:solidFill>
-            <a:srgbClr val="F1F8F2"/>
-          </a:solidFill>
-          <a:ln>
-            <a:solidFill>
-              <a:srgbClr val="F1F8F2"/>
-            </a:solidFill>
-          </a:ln>
-        </p:spPr>
-        <p:style>
-          <a:lnRef idx="1">
-            <a:schemeClr val="accent1"/>
-          </a:lnRef>
-          <a:fillRef idx="3">
-            <a:schemeClr val="accent1"/>
-          </a:fillRef>
-          <a:effectRef idx="2">
-            <a:schemeClr val="accent1"/>
-          </a:effectRef>
-          <a:fontRef idx="minor">
-            <a:schemeClr val="lt1"/>
-          </a:fontRef>
-        </p:style>
-        <p:txBody>
-          <a:bodyPr rtlCol="0" anchor="ctr"/>
-          <a:lstStyle/>
-          <a:p>
-            <a:pPr algn="ctr">
-              <a:defRPr sz="1400" b="1">
-                <a:solidFill>
-                  <a:srgbClr val="2B7A43"/>
+            <a:off x="640080" y="3200400"/>
+            <a:ext cx="11064240" cy="2057400"/>
+          </a:xfrm>
+          <a:prstGeom prst="rect">
+            <a:avLst/>
+          </a:prstGeom>
+          <a:noFill/>
+        </p:spPr>
+        <p:txBody>
+          <a:bodyPr wrap="square" lIns="73152" rIns="36576" tIns="36576" bIns="36576">
+            <a:spAutoFit/>
+          </a:bodyPr>
+          <a:lstStyle/>
+          <a:p>
+            <a:pPr>
+              <a:spcAft>
+                <a:spcPts val="300"/>
+              </a:spcAft>
+              <a:defRPr sz="1700">
+                <a:solidFill>
+                  <a:srgbClr val="191F1C"/>
                 </a:solidFill>
                 <a:latin typeface="Aptos"/>
               </a:defRPr>
             </a:pPr>
             <a:r>
-              <a:t>We are near the format's floor on clean edges. The distance worth attacking is under stress.</a:t>
+              <a:t>•  native IBIS          +34.6 ps</a:t>
+            </a:r>
+          </a:p>
+          <a:p>
+            <a:pPr>
+              <a:spcAft>
+                <a:spcPts val="300"/>
+              </a:spcAft>
+              <a:defRPr sz="1700">
+                <a:solidFill>
+                  <a:srgbClr val="191F1C"/>
+                </a:solidFill>
+                <a:latin typeface="Aptos"/>
+              </a:defRPr>
+            </a:pPr>
+            <a:r>
+              <a:t>•  our model, stock     +38.4 ps</a:t>
+            </a:r>
+          </a:p>
+          <a:p>
+            <a:pPr>
+              <a:spcAft>
+                <a:spcPts val="300"/>
+              </a:spcAft>
+              <a:defRPr sz="1700">
+                <a:solidFill>
+                  <a:srgbClr val="191F1C"/>
+                </a:solidFill>
+                <a:latin typeface="Aptos"/>
+              </a:defRPr>
+            </a:pPr>
+            <a:r>
+              <a:t>•  our model, gate-state  +43.5 ps</a:t>
+            </a:r>
+          </a:p>
+        </p:txBody>
+      </p:sp>
+      <p:sp>
+        <p:nvSpPr>
+          <p:cNvPr id="7" name="TextBox 6"/>
+          <p:cNvSpPr txBox="1"/>
+          <p:nvPr/>
+        </p:nvSpPr>
+        <p:spPr>
+          <a:xfrm>
+            <a:off x="640080" y="5029200"/>
+            <a:ext cx="10972800" cy="731520"/>
+          </a:xfrm>
+          <a:prstGeom prst="rect">
+            <a:avLst/>
+          </a:prstGeom>
+          <a:noFill/>
+        </p:spPr>
+        <p:txBody>
+          <a:bodyPr wrap="square" lIns="45720" rIns="45720" anchor="t">
+            <a:spAutoFit/>
+          </a:bodyPr>
+          <a:lstStyle/>
+          <a:p>
+            <a:pPr algn="l">
+              <a:defRPr sz="1700" b="0">
+                <a:solidFill>
+                  <a:srgbClr val="191F1C"/>
+                </a:solidFill>
+                <a:latin typeface="Aptos"/>
+              </a:defRPr>
+            </a:pPr>
+            <a:r>
+              <a:t>So the IBIS format itself costs about 35 ps, which native pays too. Our command layer costs about 5 ps on top.</a:t>
             </a:r>
           </a:p>
         </p:txBody>
@@ -5288,7 +4748,7 @@
               </a:defRPr>
             </a:pPr>
             <a:r>
-              <a:t>Where the error actually comes from</a:t>
+              <a:t>At full swing all three agree</a:t>
             </a:r>
           </a:p>
         </p:txBody>
@@ -5331,14 +4791,69 @@
       </p:sp>
       <p:sp>
         <p:nvSpPr>
-          <p:cNvPr id="4" name="Rectangle 3"/>
+          <p:cNvPr id="4" name="TextBox 3"/>
+          <p:cNvSpPr txBox="1"/>
+          <p:nvPr/>
+        </p:nvSpPr>
+        <p:spPr>
+          <a:xfrm>
+            <a:off x="640080" y="1170432"/>
+            <a:ext cx="11064240" cy="1371600"/>
+          </a:xfrm>
+          <a:prstGeom prst="rect">
+            <a:avLst/>
+          </a:prstGeom>
+          <a:noFill/>
+        </p:spPr>
+        <p:txBody>
+          <a:bodyPr wrap="square" lIns="73152" rIns="36576" tIns="36576" bIns="36576">
+            <a:spAutoFit/>
+          </a:bodyPr>
+          <a:lstStyle/>
+          <a:p>
+            <a:pPr>
+              <a:spcAft>
+                <a:spcPts val="300"/>
+              </a:spcAft>
+              <a:defRPr sz="1700">
+                <a:solidFill>
+                  <a:srgbClr val="191F1C"/>
+                </a:solidFill>
+                <a:latin typeface="Aptos"/>
+              </a:defRPr>
+            </a:pPr>
+            <a:r>
+              <a:t>•  The three curves sit on top of each other through the transition.</a:t>
+            </a:r>
+          </a:p>
+          <a:p>
+            <a:pPr>
+              <a:spcAft>
+                <a:spcPts val="300"/>
+              </a:spcAft>
+              <a:defRPr sz="1700">
+                <a:solidFill>
+                  <a:srgbClr val="191F1C"/>
+                </a:solidFill>
+                <a:latin typeface="Aptos"/>
+              </a:defRPr>
+            </a:pPr>
+            <a:r>
+              <a:t>•  What is left on the falling edge is the format's ~35 ps, not our layer.</a:t>
+            </a:r>
+          </a:p>
+        </p:txBody>
+      </p:sp>
+      <p:sp>
+        <p:nvSpPr>
+          <p:cNvPr id="5" name="Rectangle 4"/>
           <p:cNvSpPr/>
           <p:nvPr/>
         </p:nvSpPr>
         <p:spPr>
           <a:xfrm>
-            <a:off x="475488" y="1207008"/>
-            <a:ext cx="11210544" cy="4535423"/>
+            <a:off x="743653" y="1819656"/>
+            <a:ext cx="10674213" cy="4581144"/>
           </a:xfrm>
           <a:prstGeom prst="rect">
             <a:avLst/>
@@ -5376,7 +4891,7 @@
       </p:sp>
       <p:pic>
         <p:nvPicPr>
-          <p:cNvPr id="5" name="Picture 4" descr="error_budget.png"/>
+          <p:cNvPr id="6" name="Picture 5" descr="clean_edge.png"/>
           <p:cNvPicPr>
             <a:picLocks noChangeAspect="1"/>
           </p:cNvPicPr>
@@ -5390,69 +4905,14 @@
         </p:blipFill>
         <p:spPr>
           <a:xfrm>
-            <a:off x="502920" y="1234440"/>
-            <a:ext cx="11155680" cy="4480559"/>
+            <a:off x="771085" y="1847088"/>
+            <a:ext cx="10619349" cy="4526280"/>
           </a:xfrm>
           <a:prstGeom prst="rect">
             <a:avLst/>
           </a:prstGeom>
         </p:spPr>
       </p:pic>
-      <p:sp>
-        <p:nvSpPr>
-          <p:cNvPr id="6" name="Rectangle 5"/>
-          <p:cNvSpPr/>
-          <p:nvPr/>
-        </p:nvSpPr>
-        <p:spPr>
-          <a:xfrm>
-            <a:off x="384048" y="6062472"/>
-            <a:ext cx="11109960" cy="393192"/>
-          </a:xfrm>
-          <a:prstGeom prst="rect">
-            <a:avLst/>
-          </a:prstGeom>
-          <a:solidFill>
-            <a:srgbClr val="F1F8F2"/>
-          </a:solidFill>
-          <a:ln>
-            <a:solidFill>
-              <a:srgbClr val="F1F8F2"/>
-            </a:solidFill>
-          </a:ln>
-        </p:spPr>
-        <p:style>
-          <a:lnRef idx="1">
-            <a:schemeClr val="accent1"/>
-          </a:lnRef>
-          <a:fillRef idx="3">
-            <a:schemeClr val="accent1"/>
-          </a:fillRef>
-          <a:effectRef idx="2">
-            <a:schemeClr val="accent1"/>
-          </a:effectRef>
-          <a:fontRef idx="minor">
-            <a:schemeClr val="lt1"/>
-          </a:fontRef>
-        </p:style>
-        <p:txBody>
-          <a:bodyPr rtlCol="0" anchor="ctr"/>
-          <a:lstStyle/>
-          <a:p>
-            <a:pPr algn="ctr">
-              <a:defRPr sz="1400" b="1">
-                <a:solidFill>
-                  <a:srgbClr val="2B7A43"/>
-                </a:solidFill>
-                <a:latin typeface="Aptos"/>
-              </a:defRPr>
-            </a:pPr>
-            <a:r>
-              <a:t>The format costs ~35 ps. Our command layer costs ~5 ps on top. We are near the floor on clean edges.</a:t>
-            </a:r>
-          </a:p>
-        </p:txBody>
-      </p:sp>
     </p:spTree>
   </p:cSld>
   <p:clrMapOvr>
@@ -5495,7 +4955,7 @@
               </a:defRPr>
             </a:pPr>
             <a:r>
-              <a:t>On a clean edge, all three agree</a:t>
+              <a:t>Under a truncated pulse, two things go wrong</a:t>
             </a:r>
           </a:p>
         </p:txBody>
@@ -5531,21 +4991,76 @@
               </a:defRPr>
             </a:pPr>
             <a:r>
-              <a:t>WHERE WE ARE</a:t>
-            </a:r>
-          </a:p>
-        </p:txBody>
-      </p:sp>
-      <p:sp>
-        <p:nvSpPr>
-          <p:cNvPr id="4" name="Rectangle 3"/>
+              <a:t>THE TWO DEFECTS</a:t>
+            </a:r>
+          </a:p>
+        </p:txBody>
+      </p:sp>
+      <p:sp>
+        <p:nvSpPr>
+          <p:cNvPr id="4" name="TextBox 3"/>
+          <p:cNvSpPr txBox="1"/>
+          <p:nvPr/>
+        </p:nvSpPr>
+        <p:spPr>
+          <a:xfrm>
+            <a:off x="640080" y="1170432"/>
+            <a:ext cx="11064240" cy="1371600"/>
+          </a:xfrm>
+          <a:prstGeom prst="rect">
+            <a:avLst/>
+          </a:prstGeom>
+          <a:noFill/>
+        </p:spPr>
+        <p:txBody>
+          <a:bodyPr wrap="square" lIns="73152" rIns="36576" tIns="36576" bIns="36576">
+            <a:spAutoFit/>
+          </a:bodyPr>
+          <a:lstStyle/>
+          <a:p>
+            <a:pPr>
+              <a:spcAft>
+                <a:spcPts val="300"/>
+              </a:spcAft>
+              <a:defRPr sz="1700">
+                <a:solidFill>
+                  <a:srgbClr val="191F1C"/>
+                </a:solidFill>
+                <a:latin typeface="Aptos"/>
+              </a:defRPr>
+            </a:pPr>
+            <a:r>
+              <a:t>•  The input reverses before the pad finishes its transition.</a:t>
+            </a:r>
+          </a:p>
+          <a:p>
+            <a:pPr>
+              <a:spcAft>
+                <a:spcPts val="300"/>
+              </a:spcAft>
+              <a:defRPr sz="1700">
+                <a:solidFill>
+                  <a:srgbClr val="191F1C"/>
+                </a:solidFill>
+                <a:latin typeface="Aptos"/>
+              </a:defRPr>
+            </a:pPr>
+            <a:r>
+              <a:t>•  Left: the pad comes back up. Right: Ku stays part-on instead of returning.</a:t>
+            </a:r>
+          </a:p>
+        </p:txBody>
+      </p:sp>
+      <p:sp>
+        <p:nvSpPr>
+          <p:cNvPr id="5" name="Rectangle 4"/>
           <p:cNvSpPr/>
           <p:nvPr/>
         </p:nvSpPr>
         <p:spPr>
           <a:xfrm>
-            <a:off x="475488" y="1143000"/>
-            <a:ext cx="11210544" cy="4809743"/>
+            <a:off x="513743" y="2057400"/>
+            <a:ext cx="5373312" cy="4398264"/>
           </a:xfrm>
           <a:prstGeom prst="rect">
             <a:avLst/>
@@ -5583,7 +5098,7 @@
       </p:sp>
       <p:pic>
         <p:nvPicPr>
-          <p:cNvPr id="5" name="Picture 4" descr="clean_edge.png"/>
+          <p:cNvPr id="6" name="Picture 5" descr="stress_pad.png"/>
           <p:cNvPicPr>
             <a:picLocks noChangeAspect="1"/>
           </p:cNvPicPr>
@@ -5597,8 +5112,8 @@
         </p:blipFill>
         <p:spPr>
           <a:xfrm>
-            <a:off x="502920" y="1170432"/>
-            <a:ext cx="11155680" cy="4754879"/>
+            <a:off x="541175" y="2084831"/>
+            <a:ext cx="5318448" cy="4343400"/>
           </a:xfrm>
           <a:prstGeom prst="rect">
             <a:avLst/>
@@ -5607,24 +5122,24 @@
       </p:pic>
       <p:sp>
         <p:nvSpPr>
-          <p:cNvPr id="6" name="Rectangle 5"/>
+          <p:cNvPr id="7" name="Rectangle 6"/>
           <p:cNvSpPr/>
           <p:nvPr/>
         </p:nvSpPr>
         <p:spPr>
           <a:xfrm>
-            <a:off x="384048" y="6062472"/>
-            <a:ext cx="11109960" cy="393192"/>
+            <a:off x="6274463" y="2057400"/>
+            <a:ext cx="5373312" cy="4398264"/>
           </a:xfrm>
           <a:prstGeom prst="rect">
             <a:avLst/>
           </a:prstGeom>
           <a:solidFill>
-            <a:srgbClr val="F1F8F2"/>
+            <a:srgbClr val="FFFFFF"/>
           </a:solidFill>
-          <a:ln>
+          <a:ln w="10160">
             <a:solidFill>
-              <a:srgbClr val="F1F8F2"/>
+              <a:srgbClr val="CBD0CC"/>
             </a:solidFill>
           </a:ln>
         </p:spPr>
@@ -5646,20 +5161,34 @@
           <a:bodyPr rtlCol="0" anchor="ctr"/>
           <a:lstStyle/>
           <a:p>
-            <a:pPr algn="ctr">
-              <a:defRPr sz="1400" b="1">
-                <a:solidFill>
-                  <a:srgbClr val="2B7A43"/>
-                </a:solidFill>
-                <a:latin typeface="Aptos"/>
-              </a:defRPr>
-            </a:pPr>
-            <a:r>
-              <a:t>The gap left on the falling edge is what the format costs. We did not create it.</a:t>
-            </a:r>
-          </a:p>
-        </p:txBody>
-      </p:sp>
+            <a:pPr algn="ctr"/>
+          </a:p>
+        </p:txBody>
+      </p:sp>
+      <p:pic>
+        <p:nvPicPr>
+          <p:cNvPr id="8" name="Picture 7" descr="stress_kukd.png"/>
+          <p:cNvPicPr>
+            <a:picLocks noChangeAspect="1"/>
+          </p:cNvPicPr>
+          <p:nvPr/>
+        </p:nvPicPr>
+        <p:blipFill>
+          <a:blip r:embed="rId3"/>
+          <a:stretch>
+            <a:fillRect/>
+          </a:stretch>
+        </p:blipFill>
+        <p:spPr>
+          <a:xfrm>
+            <a:off x="6301895" y="2084831"/>
+            <a:ext cx="5318448" cy="4343400"/>
+          </a:xfrm>
+          <a:prstGeom prst="rect">
+            <a:avLst/>
+          </a:prstGeom>
+        </p:spPr>
+      </p:pic>
     </p:spTree>
   </p:cSld>
   <p:clrMapOvr>
@@ -5702,7 +5231,7 @@
               </a:defRPr>
             </a:pPr>
             <a:r>
-              <a:t>Under stress there are two problems</a:t>
+              <a:t>The offset: charge stranded in the command capacitor</a:t>
             </a:r>
           </a:p>
         </p:txBody>
@@ -5751,8 +5280,8 @@
         </p:nvSpPr>
         <p:spPr>
           <a:xfrm>
-            <a:off x="640080" y="1188720"/>
-            <a:ext cx="10972800" cy="914400"/>
+            <a:off x="640080" y="1170432"/>
+            <a:ext cx="11064240" cy="1371600"/>
           </a:xfrm>
           <a:prstGeom prst="rect">
             <a:avLst/>
@@ -5760,13 +5289,16 @@
           <a:noFill/>
         </p:spPr>
         <p:txBody>
-          <a:bodyPr wrap="square" lIns="45720" rIns="45720" anchor="t">
+          <a:bodyPr wrap="square" lIns="73152" rIns="36576" tIns="36576" bIns="36576">
             <a:spAutoFit/>
           </a:bodyPr>
           <a:lstStyle/>
           <a:p>
-            <a:pPr algn="l">
-              <a:defRPr sz="1700" b="0">
+            <a:pPr>
+              <a:spcAft>
+                <a:spcPts val="300"/>
+              </a:spcAft>
+              <a:defRPr sz="1700">
                 <a:solidFill>
                   <a:srgbClr val="191F1C"/>
                 </a:solidFill>
@@ -5774,31 +5306,47 @@
               </a:defRPr>
             </a:pPr>
             <a:r>
-              <a:t>Stress means a truncated pulse: the input reverses before the pad finishes its transition. Targets are 90/80/70/60/50% of the transistor's settled swing.</a:t>
-            </a:r>
-          </a:p>
-        </p:txBody>
-      </p:sp>
-      <p:sp>
-        <p:nvSpPr>
-          <p:cNvPr id="5" name="Rounded Rectangle 4"/>
+              <a:t>•  GUPCMD is a capacitor across 1e15 ohm, charged once per input edge.</a:t>
+            </a:r>
+          </a:p>
+          <a:p>
+            <a:pPr>
+              <a:spcAft>
+                <a:spcPts val="300"/>
+              </a:spcAft>
+              <a:defRPr sz="1700">
+                <a:solidFill>
+                  <a:srgbClr val="191F1C"/>
+                </a:solidFill>
+                <a:latin typeface="Aptos"/>
+              </a:defRPr>
+            </a:pPr>
+            <a:r>
+              <a:t>•  A truncated pulse leaves charge in it with no resistive path out.</a:t>
+            </a:r>
+          </a:p>
+        </p:txBody>
+      </p:sp>
+      <p:sp>
+        <p:nvSpPr>
+          <p:cNvPr id="5" name="Rectangle 4"/>
           <p:cNvSpPr/>
           <p:nvPr/>
         </p:nvSpPr>
         <p:spPr>
           <a:xfrm>
-            <a:off x="640080" y="2377440"/>
-            <a:ext cx="10972800" cy="2118105"/>
-          </a:xfrm>
-          <a:prstGeom prst="roundRect">
+            <a:off x="743653" y="1819656"/>
+            <a:ext cx="10674213" cy="4581144"/>
+          </a:xfrm>
+          <a:prstGeom prst="rect">
             <a:avLst/>
           </a:prstGeom>
           <a:solidFill>
-            <a:srgbClr val="F6F8F7"/>
+            <a:srgbClr val="FFFFFF"/>
           </a:solidFill>
-          <a:ln w="12700">
+          <a:ln w="10160">
             <a:solidFill>
-              <a:srgbClr val="A4AEA8"/>
+              <a:srgbClr val="CBD0CC"/>
             </a:solidFill>
           </a:ln>
         </p:spPr>
@@ -5817,153 +5365,37 @@
           </a:fontRef>
         </p:style>
         <p:txBody>
-          <a:bodyPr rtlCol="0" anchor="t" wrap="none" lIns="118872" rIns="73152" tIns="91440" bIns="73152"/>
-          <a:lstStyle/>
-          <a:p>
-            <a:pPr algn="l">
-              <a:defRPr sz="1700">
-                <a:solidFill>
-                  <a:srgbClr val="1E3027"/>
-                </a:solidFill>
-                <a:latin typeface="Consolas"/>
-              </a:defRPr>
-            </a:pPr>
-            <a:r>
-              <a:t>The offset         a settled-state Ku error, on 90/60/50 only.</a:t>
-            </a:r>
-          </a:p>
-          <a:p>
-            <a:pPr algn="l">
-              <a:defRPr sz="1700">
-                <a:solidFill>
-                  <a:srgbClr val="1E3027"/>
-                </a:solidFill>
-                <a:latin typeface="Consolas"/>
-              </a:defRPr>
-            </a:pPr>
-            <a:r>
-              <a:t>                   A ~6 ns tail that looks permanent on a</a:t>
-            </a:r>
-          </a:p>
-          <a:p>
-            <a:pPr algn="l">
-              <a:defRPr sz="1700">
-                <a:solidFill>
-                  <a:srgbClr val="1E3027"/>
-                </a:solidFill>
-                <a:latin typeface="Consolas"/>
-              </a:defRPr>
-            </a:pPr>
-            <a:r>
-              <a:t>                   10 ns plot -- not a true DC offset.</a:t>
-            </a:r>
-          </a:p>
-          <a:p>
-            <a:pPr algn="l">
-              <a:defRPr sz="1700">
-                <a:solidFill>
-                  <a:srgbClr val="1E3027"/>
-                </a:solidFill>
-                <a:latin typeface="Consolas"/>
-              </a:defRPr>
-            </a:pPr>
-          </a:p>
-          <a:p>
-            <a:pPr algn="l">
-              <a:defRPr sz="1700">
-                <a:solidFill>
-                  <a:srgbClr val="1E3027"/>
-                </a:solidFill>
-                <a:latin typeface="Consolas"/>
-              </a:defRPr>
-            </a:pPr>
-            <a:r>
-              <a:t>The timing shift   falling 50% crossing 69-99 ps late, on</a:t>
-            </a:r>
-          </a:p>
-          <a:p>
-            <a:pPr algn="l">
-              <a:defRPr sz="1700">
-                <a:solidFill>
-                  <a:srgbClr val="1E3027"/>
-                </a:solidFill>
-                <a:latin typeface="Consolas"/>
-              </a:defRPr>
-            </a:pPr>
-            <a:r>
-              <a:t>                   every case, where native IBIS is</a:t>
-            </a:r>
-          </a:p>
-          <a:p>
-            <a:pPr algn="l">
-              <a:defRPr sz="1700">
-                <a:solidFill>
-                  <a:srgbClr val="1E3027"/>
-                </a:solidFill>
-                <a:latin typeface="Consolas"/>
-              </a:defRPr>
-            </a:pPr>
-            <a:r>
-              <a:t>                   5-26 ps early.</a:t>
-            </a:r>
-          </a:p>
-        </p:txBody>
-      </p:sp>
-      <p:sp>
-        <p:nvSpPr>
-          <p:cNvPr id="6" name="Rectangle 5"/>
-          <p:cNvSpPr/>
+          <a:bodyPr rtlCol="0" anchor="ctr"/>
+          <a:lstStyle/>
+          <a:p>
+            <a:pPr algn="ctr"/>
+          </a:p>
+        </p:txBody>
+      </p:sp>
+      <p:pic>
+        <p:nvPicPr>
+          <p:cNvPr id="6" name="Picture 5" descr="offset_chain.png"/>
+          <p:cNvPicPr>
+            <a:picLocks noChangeAspect="1"/>
+          </p:cNvPicPr>
           <p:nvPr/>
-        </p:nvSpPr>
-        <p:spPr>
-          <a:xfrm>
-            <a:off x="384048" y="6062472"/>
-            <a:ext cx="11109960" cy="393192"/>
-          </a:xfrm>
-          <a:prstGeom prst="rect">
-            <a:avLst/>
-          </a:prstGeom>
-          <a:solidFill>
-            <a:srgbClr val="F1F8F2"/>
-          </a:solidFill>
-          <a:ln>
-            <a:solidFill>
-              <a:srgbClr val="F1F8F2"/>
-            </a:solidFill>
-          </a:ln>
-        </p:spPr>
-        <p:style>
-          <a:lnRef idx="1">
-            <a:schemeClr val="accent1"/>
-          </a:lnRef>
-          <a:fillRef idx="3">
-            <a:schemeClr val="accent1"/>
-          </a:fillRef>
-          <a:effectRef idx="2">
-            <a:schemeClr val="accent1"/>
-          </a:effectRef>
-          <a:fontRef idx="minor">
-            <a:schemeClr val="lt1"/>
-          </a:fontRef>
-        </p:style>
-        <p:txBody>
-          <a:bodyPr rtlCol="0" anchor="ctr"/>
-          <a:lstStyle/>
-          <a:p>
-            <a:pPr algn="ctr">
-              <a:defRPr sz="1400" b="1">
-                <a:solidFill>
-                  <a:srgbClr val="2B7A43"/>
-                </a:solidFill>
-                <a:latin typeface="Aptos"/>
-              </a:defRPr>
-            </a:pPr>
-            <a:r>
-              <a:t>One is an amplitude error that decays. The other is a timing error that does not.</a:t>
-            </a:r>
-          </a:p>
-        </p:txBody>
-      </p:sp>
+        </p:nvPicPr>
+        <p:blipFill>
+          <a:blip r:embed="rId2"/>
+          <a:stretch>
+            <a:fillRect/>
+          </a:stretch>
+        </p:blipFill>
+        <p:spPr>
+          <a:xfrm>
+            <a:off x="771085" y="1847088"/>
+            <a:ext cx="10619349" cy="4526280"/>
+          </a:xfrm>
+          <a:prstGeom prst="rect">
+            <a:avLst/>
+          </a:prstGeom>
+        </p:spPr>
+      </p:pic>
     </p:spTree>
   </p:cSld>
   <p:clrMapOvr>
@@ -6006,7 +5438,7 @@
               </a:defRPr>
             </a:pPr>
             <a:r>
-              <a:t>Where the offset comes from</a:t>
+              <a:t>delay_cmd removes the offset</a:t>
             </a:r>
           </a:p>
         </p:txBody>
@@ -6049,14 +5481,69 @@
       </p:sp>
       <p:sp>
         <p:nvSpPr>
-          <p:cNvPr id="4" name="Rectangle 3"/>
+          <p:cNvPr id="4" name="TextBox 3"/>
+          <p:cNvSpPr txBox="1"/>
+          <p:nvPr/>
+        </p:nvSpPr>
+        <p:spPr>
+          <a:xfrm>
+            <a:off x="640080" y="1170432"/>
+            <a:ext cx="11064240" cy="1371600"/>
+          </a:xfrm>
+          <a:prstGeom prst="rect">
+            <a:avLst/>
+          </a:prstGeom>
+          <a:noFill/>
+        </p:spPr>
+        <p:txBody>
+          <a:bodyPr wrap="square" lIns="73152" rIns="36576" tIns="36576" bIns="36576">
+            <a:spAutoFit/>
+          </a:bodyPr>
+          <a:lstStyle/>
+          <a:p>
+            <a:pPr>
+              <a:spcAft>
+                <a:spcPts val="300"/>
+              </a:spcAft>
+              <a:defRPr sz="1700">
+                <a:solidFill>
+                  <a:srgbClr val="191F1C"/>
+                </a:solidFill>
+                <a:latin typeface="Aptos"/>
+              </a:defRPr>
+            </a:pPr>
+            <a:r>
+              <a:t>•  The command becomes a function of the input level, not of edge history.</a:t>
+            </a:r>
+          </a:p>
+          <a:p>
+            <a:pPr>
+              <a:spcAft>
+                <a:spcPts val="300"/>
+              </a:spcAft>
+              <a:defRPr sz="1700">
+                <a:solidFill>
+                  <a:srgbClr val="191F1C"/>
+                </a:solidFill>
+                <a:latin typeface="Aptos"/>
+              </a:defRPr>
+            </a:pPr>
+            <a:r>
+              <a:t>•  It returns to exactly zero, so nothing is stranded.</a:t>
+            </a:r>
+          </a:p>
+        </p:txBody>
+      </p:sp>
+      <p:sp>
+        <p:nvSpPr>
+          <p:cNvPr id="5" name="Rectangle 4"/>
           <p:cNvSpPr/>
           <p:nvPr/>
         </p:nvSpPr>
         <p:spPr>
           <a:xfrm>
-            <a:off x="475488" y="1143000"/>
-            <a:ext cx="11210544" cy="4809743"/>
+            <a:off x="743653" y="1819656"/>
+            <a:ext cx="10674213" cy="4581144"/>
           </a:xfrm>
           <a:prstGeom prst="rect">
             <a:avLst/>
@@ -6094,7 +5581,7 @@
       </p:sp>
       <p:pic>
         <p:nvPicPr>
-          <p:cNvPr id="5" name="Picture 4" descr="offset_chain.png"/>
+          <p:cNvPr id="6" name="Picture 5" descr="offset_removed.png"/>
           <p:cNvPicPr>
             <a:picLocks noChangeAspect="1"/>
           </p:cNvPicPr>
@@ -6108,69 +5595,14 @@
         </p:blipFill>
         <p:spPr>
           <a:xfrm>
-            <a:off x="502920" y="1170432"/>
-            <a:ext cx="11155680" cy="4754879"/>
+            <a:off x="771085" y="1847088"/>
+            <a:ext cx="10619349" cy="4526280"/>
           </a:xfrm>
           <a:prstGeom prst="rect">
             <a:avLst/>
           </a:prstGeom>
         </p:spPr>
       </p:pic>
-      <p:sp>
-        <p:nvSpPr>
-          <p:cNvPr id="6" name="Rectangle 5"/>
-          <p:cNvSpPr/>
-          <p:nvPr/>
-        </p:nvSpPr>
-        <p:spPr>
-          <a:xfrm>
-            <a:off x="384048" y="6062472"/>
-            <a:ext cx="11109960" cy="393192"/>
-          </a:xfrm>
-          <a:prstGeom prst="rect">
-            <a:avLst/>
-          </a:prstGeom>
-          <a:solidFill>
-            <a:srgbClr val="F1F8F2"/>
-          </a:solidFill>
-          <a:ln>
-            <a:solidFill>
-              <a:srgbClr val="F1F8F2"/>
-            </a:solidFill>
-          </a:ln>
-        </p:spPr>
-        <p:style>
-          <a:lnRef idx="1">
-            <a:schemeClr val="accent1"/>
-          </a:lnRef>
-          <a:fillRef idx="3">
-            <a:schemeClr val="accent1"/>
-          </a:fillRef>
-          <a:effectRef idx="2">
-            <a:schemeClr val="accent1"/>
-          </a:effectRef>
-          <a:fontRef idx="minor">
-            <a:schemeClr val="lt1"/>
-          </a:fontRef>
-        </p:style>
-        <p:txBody>
-          <a:bodyPr rtlCol="0" anchor="ctr"/>
-          <a:lstStyle/>
-          <a:p>
-            <a:pPr algn="ctr">
-              <a:defRPr sz="1400" b="1">
-                <a:solidFill>
-                  <a:srgbClr val="2B7A43"/>
-                </a:solidFill>
-                <a:latin typeface="Aptos"/>
-              </a:defRPr>
-            </a:pPr>
-            <a:r>
-              <a:t>GUPCMD is a capacitor across 1e15 ohm. A truncated pulse strands charge with no path to remove it.</a:t>
-            </a:r>
-          </a:p>
-        </p:txBody>
-      </p:sp>
     </p:spTree>
   </p:cSld>
   <p:clrMapOvr>
@@ -6213,7 +5645,7 @@
               </a:defRPr>
             </a:pPr>
             <a:r>
-              <a:t>delay_cmd removes it</a:t>
+              <a:t>It does not fix the timing</a:t>
             </a:r>
           </a:p>
         </p:txBody>
@@ -6256,124 +5688,182 @@
       </p:sp>
       <p:sp>
         <p:nvSpPr>
-          <p:cNvPr id="4" name="Rectangle 3"/>
-          <p:cNvSpPr/>
+          <p:cNvPr id="4" name="TextBox 3"/>
+          <p:cNvSpPr txBox="1"/>
           <p:nvPr/>
         </p:nvSpPr>
         <p:spPr>
           <a:xfrm>
-            <a:off x="475488" y="1143000"/>
-            <a:ext cx="11210544" cy="4809743"/>
-          </a:xfrm>
-          <a:prstGeom prst="rect">
-            <a:avLst/>
-          </a:prstGeom>
-          <a:solidFill>
-            <a:srgbClr val="FFFFFF"/>
-          </a:solidFill>
-          <a:ln w="10160">
-            <a:solidFill>
-              <a:srgbClr val="CBD0CC"/>
-            </a:solidFill>
-          </a:ln>
-        </p:spPr>
-        <p:style>
-          <a:lnRef idx="1">
-            <a:schemeClr val="accent1"/>
-          </a:lnRef>
-          <a:fillRef idx="3">
-            <a:schemeClr val="accent1"/>
-          </a:fillRef>
-          <a:effectRef idx="2">
-            <a:schemeClr val="accent1"/>
-          </a:effectRef>
-          <a:fontRef idx="minor">
-            <a:schemeClr val="lt1"/>
-          </a:fontRef>
-        </p:style>
-        <p:txBody>
-          <a:bodyPr rtlCol="0" anchor="ctr"/>
-          <a:lstStyle/>
-          <a:p>
-            <a:pPr algn="ctr"/>
-          </a:p>
-        </p:txBody>
-      </p:sp>
-      <p:pic>
-        <p:nvPicPr>
-          <p:cNvPr id="5" name="Picture 4" descr="offset_removed.png"/>
-          <p:cNvPicPr>
-            <a:picLocks noChangeAspect="1"/>
-          </p:cNvPicPr>
+            <a:off x="640080" y="1170432"/>
+            <a:ext cx="11064240" cy="685800"/>
+          </a:xfrm>
+          <a:prstGeom prst="rect">
+            <a:avLst/>
+          </a:prstGeom>
+          <a:noFill/>
+        </p:spPr>
+        <p:txBody>
+          <a:bodyPr wrap="square" lIns="73152" rIns="36576" tIns="36576" bIns="36576">
+            <a:spAutoFit/>
+          </a:bodyPr>
+          <a:lstStyle/>
+          <a:p>
+            <a:pPr>
+              <a:spcAft>
+                <a:spcPts val="300"/>
+              </a:spcAft>
+              <a:defRPr sz="1700">
+                <a:solidFill>
+                  <a:srgbClr val="191F1C"/>
+                </a:solidFill>
+                <a:latin typeface="Aptos"/>
+              </a:defRPr>
+            </a:pPr>
+            <a:r>
+              <a:t>•  If the offset and the timing shift were one mechanism, delay_cmd would fix both. Its amplitude had been measured; its timing never had.</a:t>
+            </a:r>
+          </a:p>
+        </p:txBody>
+      </p:sp>
+      <p:sp>
+        <p:nvSpPr>
+          <p:cNvPr id="5" name="TextBox 4"/>
+          <p:cNvSpPr txBox="1"/>
           <p:nvPr/>
-        </p:nvPicPr>
-        <p:blipFill>
-          <a:blip r:embed="rId2"/>
-          <a:stretch>
-            <a:fillRect/>
-          </a:stretch>
-        </p:blipFill>
-        <p:spPr>
-          <a:xfrm>
-            <a:off x="502920" y="1170432"/>
-            <a:ext cx="11155680" cy="4754879"/>
-          </a:xfrm>
-          <a:prstGeom prst="rect">
-            <a:avLst/>
-          </a:prstGeom>
-        </p:spPr>
-      </p:pic>
-      <p:sp>
-        <p:nvSpPr>
-          <p:cNvPr id="6" name="Rectangle 5"/>
-          <p:cNvSpPr/>
+        </p:nvSpPr>
+        <p:spPr>
+          <a:xfrm>
+            <a:off x="640080" y="2194560"/>
+            <a:ext cx="10972800" cy="457200"/>
+          </a:xfrm>
+          <a:prstGeom prst="rect">
+            <a:avLst/>
+          </a:prstGeom>
+          <a:noFill/>
+        </p:spPr>
+        <p:txBody>
+          <a:bodyPr wrap="square" lIns="45720" rIns="45720" anchor="t">
+            <a:spAutoFit/>
+          </a:bodyPr>
+          <a:lstStyle/>
+          <a:p>
+            <a:pPr algn="l">
+              <a:defRPr sz="1700" b="0">
+                <a:solidFill>
+                  <a:srgbClr val="191F1C"/>
+                </a:solidFill>
+                <a:latin typeface="Aptos"/>
+              </a:defRPr>
+            </a:pPr>
+            <a:r>
+              <a:t>We measured it:</a:t>
+            </a:r>
+          </a:p>
+        </p:txBody>
+      </p:sp>
+      <p:sp>
+        <p:nvSpPr>
+          <p:cNvPr id="6" name="TextBox 5"/>
+          <p:cNvSpPr txBox="1"/>
           <p:nvPr/>
         </p:nvSpPr>
         <p:spPr>
           <a:xfrm>
-            <a:off x="384048" y="6062472"/>
-            <a:ext cx="11109960" cy="393192"/>
-          </a:xfrm>
-          <a:prstGeom prst="rect">
-            <a:avLst/>
-          </a:prstGeom>
-          <a:solidFill>
-            <a:srgbClr val="F1F8F2"/>
-          </a:solidFill>
-          <a:ln>
-            <a:solidFill>
-              <a:srgbClr val="F1F8F2"/>
-            </a:solidFill>
-          </a:ln>
-        </p:spPr>
-        <p:style>
-          <a:lnRef idx="1">
-            <a:schemeClr val="accent1"/>
-          </a:lnRef>
-          <a:fillRef idx="3">
-            <a:schemeClr val="accent1"/>
-          </a:fillRef>
-          <a:effectRef idx="2">
-            <a:schemeClr val="accent1"/>
-          </a:effectRef>
-          <a:fontRef idx="minor">
-            <a:schemeClr val="lt1"/>
-          </a:fontRef>
-        </p:style>
-        <p:txBody>
-          <a:bodyPr rtlCol="0" anchor="ctr"/>
-          <a:lstStyle/>
-          <a:p>
-            <a:pPr algn="ctr">
-              <a:defRPr sz="1400" b="1">
-                <a:solidFill>
-                  <a:srgbClr val="2B7A43"/>
+            <a:off x="640080" y="2743200"/>
+            <a:ext cx="11064240" cy="2057400"/>
+          </a:xfrm>
+          <a:prstGeom prst="rect">
+            <a:avLst/>
+          </a:prstGeom>
+          <a:noFill/>
+        </p:spPr>
+        <p:txBody>
+          <a:bodyPr wrap="square" lIns="73152" rIns="36576" tIns="36576" bIns="36576">
+            <a:spAutoFit/>
+          </a:bodyPr>
+          <a:lstStyle/>
+          <a:p>
+            <a:pPr>
+              <a:spcAft>
+                <a:spcPts val="300"/>
+              </a:spcAft>
+              <a:defRPr sz="1700">
+                <a:solidFill>
+                  <a:srgbClr val="191F1C"/>
                 </a:solidFill>
                 <a:latin typeface="Aptos"/>
               </a:defRPr>
             </a:pPr>
             <a:r>
-              <a:t>Level-driven commands fix the offset. This part is settled.</a:t>
+              <a:t>•  delay_cmd improved the timing on 0 of 19 stress cases</a:t>
+            </a:r>
+          </a:p>
+          <a:p>
+            <a:pPr>
+              <a:spcAft>
+                <a:spcPts val="300"/>
+              </a:spcAft>
+              <a:defRPr sz="1700">
+                <a:solidFill>
+                  <a:srgbClr val="191F1C"/>
+                </a:solidFill>
+                <a:latin typeface="Aptos"/>
+              </a:defRPr>
+            </a:pPr>
+            <a:r>
+              <a:t>•  the shift persists once the stranded charge is gone</a:t>
+            </a:r>
+          </a:p>
+          <a:p>
+            <a:pPr>
+              <a:spcAft>
+                <a:spcPts val="300"/>
+              </a:spcAft>
+              <a:defRPr sz="1700">
+                <a:solidFill>
+                  <a:srgbClr val="191F1C"/>
+                </a:solidFill>
+                <a:latin typeface="Aptos"/>
+              </a:defRPr>
+            </a:pPr>
+            <a:r>
+              <a:t>•  they are two defects, not one</a:t>
+            </a:r>
+          </a:p>
+        </p:txBody>
+      </p:sp>
+      <p:sp>
+        <p:nvSpPr>
+          <p:cNvPr id="7" name="TextBox 6"/>
+          <p:cNvSpPr txBox="1"/>
+          <p:nvPr/>
+        </p:nvSpPr>
+        <p:spPr>
+          <a:xfrm>
+            <a:off x="640080" y="4663440"/>
+            <a:ext cx="10972800" cy="914400"/>
+          </a:xfrm>
+          <a:prstGeom prst="rect">
+            <a:avLst/>
+          </a:prstGeom>
+          <a:noFill/>
+        </p:spPr>
+        <p:txBody>
+          <a:bodyPr wrap="square" lIns="45720" rIns="45720" anchor="t">
+            <a:spAutoFit/>
+          </a:bodyPr>
+          <a:lstStyle/>
+          <a:p>
+            <a:pPr algn="l">
+              <a:defRPr sz="1700" b="0">
+                <a:solidFill>
+                  <a:srgbClr val="191F1C"/>
+                </a:solidFill>
+                <a:latin typeface="Aptos"/>
+              </a:defRPr>
+            </a:pPr>
+            <a:r>
+              <a:t>The offset has a fix. The timing shift has no candidate mechanism yet, and it grows as the pulse is truncated — on all nine buffer variants tested so far.</a:t>
             </a:r>
           </a:p>
         </p:txBody>
@@ -6420,7 +5910,7 @@
               </a:defRPr>
             </a:pPr>
             <a:r>
-              <a:t>It does not fix the timing</a:t>
+              <a:t>The core reconstruction is sound</a:t>
             </a:r>
           </a:p>
         </p:txBody>
@@ -6456,7 +5946,7 @@
               </a:defRPr>
             </a:pPr>
             <a:r>
-              <a:t>THE TWO DEFECTS</a:t>
+              <a:t>CONFIDENCE</a:t>
             </a:r>
           </a:p>
         </p:txBody>
@@ -6469,8 +5959,63 @@
         </p:nvSpPr>
         <p:spPr>
           <a:xfrm>
-            <a:off x="640080" y="1188720"/>
-            <a:ext cx="10972800" cy="1280160"/>
+            <a:off x="640080" y="1170432"/>
+            <a:ext cx="11064240" cy="1371600"/>
+          </a:xfrm>
+          <a:prstGeom prst="rect">
+            <a:avLst/>
+          </a:prstGeom>
+          <a:noFill/>
+        </p:spPr>
+        <p:txBody>
+          <a:bodyPr wrap="square" lIns="73152" rIns="36576" tIns="36576" bIns="36576">
+            <a:spAutoFit/>
+          </a:bodyPr>
+          <a:lstStyle/>
+          <a:p>
+            <a:pPr>
+              <a:spcAft>
+                <a:spcPts val="300"/>
+              </a:spcAft>
+              <a:defRPr sz="1700">
+                <a:solidFill>
+                  <a:srgbClr val="191F1C"/>
+                </a:solidFill>
+                <a:latin typeface="Aptos"/>
+              </a:defRPr>
+            </a:pPr>
+            <a:r>
+              <a:t>•  A golden-waveform test replays a model's own V-T tables into the fixture that produced them — no transistor, no native IBIS, no engine confound.</a:t>
+            </a:r>
+          </a:p>
+          <a:p>
+            <a:pPr>
+              <a:spcAft>
+                <a:spcPts val="300"/>
+              </a:spcAft>
+              <a:defRPr sz="1700">
+                <a:solidFill>
+                  <a:srgbClr val="191F1C"/>
+                </a:solidFill>
+                <a:latin typeface="Aptos"/>
+              </a:defRPr>
+            </a:pPr>
+            <a:r>
+              <a:t>•  We had never done this before. It is now the standing health check.</a:t>
+            </a:r>
+          </a:p>
+        </p:txBody>
+      </p:sp>
+      <p:sp>
+        <p:nvSpPr>
+          <p:cNvPr id="5" name="TextBox 4"/>
+          <p:cNvSpPr txBox="1"/>
+          <p:nvPr/>
+        </p:nvSpPr>
+        <p:spPr>
+          <a:xfrm>
+            <a:off x="640080" y="2834640"/>
+            <a:ext cx="10972800" cy="457200"/>
           </a:xfrm>
           <a:prstGeom prst="rect">
             <a:avLst/>
@@ -6492,189 +6037,98 @@
               </a:defRPr>
             </a:pPr>
             <a:r>
-              <a:t>The open question was whether the offset and the timing shift were one mechanism showing up twice. If they were, delay_cmd would already fix both. Its amplitude had been measured; its timing never had.</a:t>
-            </a:r>
-          </a:p>
-        </p:txBody>
-      </p:sp>
-      <p:sp>
-        <p:nvSpPr>
-          <p:cNvPr id="5" name="Rounded Rectangle 4"/>
-          <p:cNvSpPr/>
+              <a:t>Our model against its own golden waveforms, three buffers, both edges, both fixtures:</a:t>
+            </a:r>
+          </a:p>
+        </p:txBody>
+      </p:sp>
+      <p:sp>
+        <p:nvSpPr>
+          <p:cNvPr id="6" name="TextBox 5"/>
+          <p:cNvSpPr txBox="1"/>
           <p:nvPr/>
         </p:nvSpPr>
         <p:spPr>
           <a:xfrm>
-            <a:off x="640080" y="2743200"/>
-            <a:ext cx="10972800" cy="2118105"/>
-          </a:xfrm>
-          <a:prstGeom prst="roundRect">
-            <a:avLst/>
-          </a:prstGeom>
-          <a:solidFill>
-            <a:srgbClr val="F6F8F7"/>
-          </a:solidFill>
-          <a:ln w="12700">
-            <a:solidFill>
-              <a:srgbClr val="A4AEA8"/>
-            </a:solidFill>
-          </a:ln>
-        </p:spPr>
-        <p:style>
-          <a:lnRef idx="1">
-            <a:schemeClr val="accent1"/>
-          </a:lnRef>
-          <a:fillRef idx="3">
-            <a:schemeClr val="accent1"/>
-          </a:fillRef>
-          <a:effectRef idx="2">
-            <a:schemeClr val="accent1"/>
-          </a:effectRef>
-          <a:fontRef idx="minor">
-            <a:schemeClr val="lt1"/>
-          </a:fontRef>
-        </p:style>
-        <p:txBody>
-          <a:bodyPr rtlCol="0" anchor="t" wrap="none" lIns="118872" rIns="73152" tIns="91440" bIns="73152"/>
+            <a:off x="640080" y="3383280"/>
+            <a:ext cx="11064240" cy="1371600"/>
+          </a:xfrm>
+          <a:prstGeom prst="rect">
+            <a:avLst/>
+          </a:prstGeom>
+          <a:noFill/>
+        </p:spPr>
+        <p:txBody>
+          <a:bodyPr wrap="square" lIns="73152" rIns="36576" tIns="36576" bIns="36576">
+            <a:spAutoFit/>
+          </a:bodyPr>
+          <a:lstStyle/>
+          <a:p>
+            <a:pPr>
+              <a:spcAft>
+                <a:spcPts val="300"/>
+              </a:spcAft>
+              <a:defRPr sz="1700">
+                <a:solidFill>
+                  <a:srgbClr val="191F1C"/>
+                </a:solidFill>
+                <a:latin typeface="Aptos"/>
+              </a:defRPr>
+            </a:pPr>
+            <a:r>
+              <a:t>•  figure of merit   0.03 – 0.41 %</a:t>
+            </a:r>
+          </a:p>
+          <a:p>
+            <a:pPr>
+              <a:spcAft>
+                <a:spcPts val="300"/>
+              </a:spcAft>
+              <a:defRPr sz="1700">
+                <a:solidFill>
+                  <a:srgbClr val="191F1C"/>
+                </a:solidFill>
+                <a:latin typeface="Aptos"/>
+              </a:defRPr>
+            </a:pPr>
+            <a:r>
+              <a:t>•  timing shift      +4 to +8 ps</a:t>
+            </a:r>
+          </a:p>
+        </p:txBody>
+      </p:sp>
+      <p:sp>
+        <p:nvSpPr>
+          <p:cNvPr id="7" name="TextBox 6"/>
+          <p:cNvSpPr txBox="1"/>
+          <p:nvPr/>
+        </p:nvSpPr>
+        <p:spPr>
+          <a:xfrm>
+            <a:off x="640080" y="4572000"/>
+            <a:ext cx="10972800" cy="731520"/>
+          </a:xfrm>
+          <a:prstGeom prst="rect">
+            <a:avLst/>
+          </a:prstGeom>
+          <a:noFill/>
+        </p:spPr>
+        <p:txBody>
+          <a:bodyPr wrap="square" lIns="45720" rIns="45720" anchor="t">
+            <a:spAutoFit/>
+          </a:bodyPr>
           <a:lstStyle/>
           <a:p>
             <a:pPr algn="l">
-              <a:defRPr sz="1700">
-                <a:solidFill>
-                  <a:srgbClr val="1E3027"/>
-                </a:solidFill>
-                <a:latin typeface="Consolas"/>
-              </a:defRPr>
-            </a:pPr>
-            <a:r>
-              <a:t>We measured it.</a:t>
-            </a:r>
-          </a:p>
-          <a:p>
-            <a:pPr algn="l">
-              <a:defRPr sz="1700">
-                <a:solidFill>
-                  <a:srgbClr val="1E3027"/>
-                </a:solidFill>
-                <a:latin typeface="Consolas"/>
-              </a:defRPr>
-            </a:pPr>
-          </a:p>
-          <a:p>
-            <a:pPr algn="l">
-              <a:defRPr sz="1700">
-                <a:solidFill>
-                  <a:srgbClr val="1E3027"/>
-                </a:solidFill>
-                <a:latin typeface="Consolas"/>
-              </a:defRPr>
-            </a:pPr>
-            <a:r>
-              <a:t>  delay_cmd improved the timing on 0 of 19 stress cases.</a:t>
-            </a:r>
-          </a:p>
-          <a:p>
-            <a:pPr algn="l">
-              <a:defRPr sz="1700">
-                <a:solidFill>
-                  <a:srgbClr val="1E3027"/>
-                </a:solidFill>
-                <a:latin typeface="Consolas"/>
-              </a:defRPr>
-            </a:pPr>
-          </a:p>
-          <a:p>
-            <a:pPr algn="l">
-              <a:defRPr sz="1700">
-                <a:solidFill>
-                  <a:srgbClr val="1E3027"/>
-                </a:solidFill>
-                <a:latin typeface="Consolas"/>
-              </a:defRPr>
-            </a:pPr>
-            <a:r>
-              <a:t>  -&gt; the shift persists once the stranded charge is gone</a:t>
-            </a:r>
-          </a:p>
-          <a:p>
-            <a:pPr algn="l">
-              <a:defRPr sz="1700">
-                <a:solidFill>
-                  <a:srgbClr val="1E3027"/>
-                </a:solidFill>
-                <a:latin typeface="Consolas"/>
-              </a:defRPr>
-            </a:pPr>
-            <a:r>
-              <a:t>  -&gt; they are two defects, not one</a:t>
-            </a:r>
-          </a:p>
-          <a:p>
-            <a:pPr algn="l">
-              <a:defRPr sz="1700">
-                <a:solidFill>
-                  <a:srgbClr val="1E3027"/>
-                </a:solidFill>
-                <a:latin typeface="Consolas"/>
-              </a:defRPr>
-            </a:pPr>
-            <a:r>
-              <a:t>  -&gt; the offset has a fix; the shift has no mechanism yet</a:t>
-            </a:r>
-          </a:p>
-        </p:txBody>
-      </p:sp>
-      <p:sp>
-        <p:nvSpPr>
-          <p:cNvPr id="6" name="Rectangle 5"/>
-          <p:cNvSpPr/>
-          <p:nvPr/>
-        </p:nvSpPr>
-        <p:spPr>
-          <a:xfrm>
-            <a:off x="384048" y="6062472"/>
-            <a:ext cx="11109960" cy="393192"/>
-          </a:xfrm>
-          <a:prstGeom prst="rect">
-            <a:avLst/>
-          </a:prstGeom>
-          <a:solidFill>
-            <a:srgbClr val="F1F8F2"/>
-          </a:solidFill>
-          <a:ln>
-            <a:solidFill>
-              <a:srgbClr val="F1F8F2"/>
-            </a:solidFill>
-          </a:ln>
-        </p:spPr>
-        <p:style>
-          <a:lnRef idx="1">
-            <a:schemeClr val="accent1"/>
-          </a:lnRef>
-          <a:fillRef idx="3">
-            <a:schemeClr val="accent1"/>
-          </a:fillRef>
-          <a:effectRef idx="2">
-            <a:schemeClr val="accent1"/>
-          </a:effectRef>
-          <a:fontRef idx="minor">
-            <a:schemeClr val="lt1"/>
-          </a:fontRef>
-        </p:style>
-        <p:txBody>
-          <a:bodyPr rtlCol="0" anchor="ctr"/>
-          <a:lstStyle/>
-          <a:p>
-            <a:pPr algn="ctr">
-              <a:defRPr sz="1400" b="1">
-                <a:solidFill>
-                  <a:srgbClr val="2B7A43"/>
+              <a:defRPr sz="1700" b="0">
+                <a:solidFill>
+                  <a:srgbClr val="191F1C"/>
                 </a:solidFill>
                 <a:latin typeface="Aptos"/>
               </a:defRPr>
             </a:pPr>
             <a:r>
-              <a:t>A cheap experiment closed a question that was open for weeks, with the less convenient answer.</a:t>
+              <a:t>So whatever is wrong under stress, it is not the I-V × Ku(t) reconstruction.</a:t>
             </a:r>
           </a:p>
         </p:txBody>
@@ -6721,7 +6175,7 @@
               </a:defRPr>
             </a:pPr>
             <a:r>
-              <a:t>The shift grows as the pulse is truncated</a:t>
+              <a:t>C_comp is handled correctly</a:t>
             </a:r>
           </a:p>
         </p:txBody>
@@ -6757,131 +6211,189 @@
               </a:defRPr>
             </a:pPr>
             <a:r>
-              <a:t>THE TWO DEFECTS</a:t>
-            </a:r>
-          </a:p>
-        </p:txBody>
-      </p:sp>
-      <p:sp>
-        <p:nvSpPr>
-          <p:cNvPr id="4" name="Rectangle 3"/>
-          <p:cNvSpPr/>
+              <a:t>CONFIDENCE</a:t>
+            </a:r>
+          </a:p>
+        </p:txBody>
+      </p:sp>
+      <p:sp>
+        <p:nvSpPr>
+          <p:cNvPr id="4" name="TextBox 3"/>
+          <p:cNvSpPr txBox="1"/>
           <p:nvPr/>
         </p:nvSpPr>
         <p:spPr>
           <a:xfrm>
-            <a:off x="475488" y="1143000"/>
-            <a:ext cx="11210544" cy="4809743"/>
-          </a:xfrm>
-          <a:prstGeom prst="rect">
-            <a:avLst/>
-          </a:prstGeom>
-          <a:solidFill>
-            <a:srgbClr val="FFFFFF"/>
-          </a:solidFill>
-          <a:ln w="10160">
-            <a:solidFill>
-              <a:srgbClr val="CBD0CC"/>
-            </a:solidFill>
-          </a:ln>
-        </p:spPr>
-        <p:style>
-          <a:lnRef idx="1">
-            <a:schemeClr val="accent1"/>
-          </a:lnRef>
-          <a:fillRef idx="3">
-            <a:schemeClr val="accent1"/>
-          </a:fillRef>
-          <a:effectRef idx="2">
-            <a:schemeClr val="accent1"/>
-          </a:effectRef>
-          <a:fontRef idx="minor">
-            <a:schemeClr val="lt1"/>
-          </a:fontRef>
-        </p:style>
-        <p:txBody>
-          <a:bodyPr rtlCol="0" anchor="ctr"/>
-          <a:lstStyle/>
-          <a:p>
-            <a:pPr algn="ctr"/>
-          </a:p>
-        </p:txBody>
-      </p:sp>
-      <p:pic>
-        <p:nvPicPr>
-          <p:cNvPr id="5" name="Picture 4" descr="shift_vs_depth.png"/>
-          <p:cNvPicPr>
-            <a:picLocks noChangeAspect="1"/>
-          </p:cNvPicPr>
+            <a:off x="640080" y="1170432"/>
+            <a:ext cx="11064240" cy="685800"/>
+          </a:xfrm>
+          <a:prstGeom prst="rect">
+            <a:avLst/>
+          </a:prstGeom>
+          <a:noFill/>
+        </p:spPr>
+        <p:txBody>
+          <a:bodyPr wrap="square" lIns="73152" rIns="36576" tIns="36576" bIns="36576">
+            <a:spAutoFit/>
+          </a:bodyPr>
+          <a:lstStyle/>
+          <a:p>
+            <a:pPr>
+              <a:spcAft>
+                <a:spcPts val="300"/>
+              </a:spcAft>
+              <a:defRPr sz="1700">
+                <a:solidFill>
+                  <a:srgbClr val="191F1C"/>
+                </a:solidFill>
+                <a:latin typeface="Aptos"/>
+              </a:defRPr>
+            </a:pPr>
+            <a:r>
+              <a:t>•  Nominal C_comp beats zero on all 12 tables, and the margin scales with the die capacitance.</a:t>
+            </a:r>
+          </a:p>
+        </p:txBody>
+      </p:sp>
+      <p:sp>
+        <p:nvSpPr>
+          <p:cNvPr id="5" name="TextBox 4"/>
+          <p:cNvSpPr txBox="1"/>
           <p:nvPr/>
-        </p:nvPicPr>
-        <p:blipFill>
-          <a:blip r:embed="rId2"/>
-          <a:stretch>
-            <a:fillRect/>
-          </a:stretch>
-        </p:blipFill>
-        <p:spPr>
-          <a:xfrm>
-            <a:off x="502920" y="1170432"/>
-            <a:ext cx="11155680" cy="4754879"/>
-          </a:xfrm>
-          <a:prstGeom prst="rect">
-            <a:avLst/>
-          </a:prstGeom>
-        </p:spPr>
-      </p:pic>
-      <p:sp>
-        <p:nvSpPr>
-          <p:cNvPr id="6" name="Rectangle 5"/>
-          <p:cNvSpPr/>
+        </p:nvSpPr>
+        <p:spPr>
+          <a:xfrm>
+            <a:off x="640080" y="2011680"/>
+            <a:ext cx="10972800" cy="457200"/>
+          </a:xfrm>
+          <a:prstGeom prst="rect">
+            <a:avLst/>
+          </a:prstGeom>
+          <a:noFill/>
+        </p:spPr>
+        <p:txBody>
+          <a:bodyPr wrap="square" lIns="45720" rIns="45720" anchor="t">
+            <a:spAutoFit/>
+          </a:bodyPr>
+          <a:lstStyle/>
+          <a:p>
+            <a:pPr algn="l">
+              <a:defRPr sz="1700" b="0">
+                <a:solidFill>
+                  <a:srgbClr val="191F1C"/>
+                </a:solidFill>
+                <a:latin typeface="Aptos"/>
+              </a:defRPr>
+            </a:pPr>
+            <a:r>
+              <a:t>50% crossing shift against the transistor, with C_comp at nominal and set to zero:</a:t>
+            </a:r>
+          </a:p>
+        </p:txBody>
+      </p:sp>
+      <p:sp>
+        <p:nvSpPr>
+          <p:cNvPr id="6" name="TextBox 5"/>
+          <p:cNvSpPr txBox="1"/>
           <p:nvPr/>
         </p:nvSpPr>
         <p:spPr>
           <a:xfrm>
-            <a:off x="384048" y="6062472"/>
-            <a:ext cx="11109960" cy="393192"/>
-          </a:xfrm>
-          <a:prstGeom prst="rect">
-            <a:avLst/>
-          </a:prstGeom>
-          <a:solidFill>
-            <a:srgbClr val="F1F8F2"/>
-          </a:solidFill>
-          <a:ln>
-            <a:solidFill>
-              <a:srgbClr val="F1F8F2"/>
-            </a:solidFill>
-          </a:ln>
-        </p:spPr>
-        <p:style>
-          <a:lnRef idx="1">
-            <a:schemeClr val="accent1"/>
-          </a:lnRef>
-          <a:fillRef idx="3">
-            <a:schemeClr val="accent1"/>
-          </a:fillRef>
-          <a:effectRef idx="2">
-            <a:schemeClr val="accent1"/>
-          </a:effectRef>
-          <a:fontRef idx="minor">
-            <a:schemeClr val="lt1"/>
-          </a:fontRef>
-        </p:style>
-        <p:txBody>
-          <a:bodyPr rtlCol="0" anchor="ctr"/>
-          <a:lstStyle/>
-          <a:p>
-            <a:pPr algn="ctr">
-              <a:defRPr sz="1400" b="1">
-                <a:solidFill>
-                  <a:srgbClr val="2B7A43"/>
+            <a:off x="640080" y="2560320"/>
+            <a:ext cx="11064240" cy="2057400"/>
+          </a:xfrm>
+          <a:prstGeom prst="rect">
+            <a:avLst/>
+          </a:prstGeom>
+          <a:noFill/>
+        </p:spPr>
+        <p:txBody>
+          <a:bodyPr wrap="square" lIns="73152" rIns="36576" tIns="36576" bIns="36576">
+            <a:spAutoFit/>
+          </a:bodyPr>
+          <a:lstStyle/>
+          <a:p>
+            <a:pPr>
+              <a:spcAft>
+                <a:spcPts val="300"/>
+              </a:spcAft>
+              <a:defRPr sz="1700">
+                <a:solidFill>
+                  <a:srgbClr val="191F1C"/>
                 </a:solidFill>
                 <a:latin typeface="Aptos"/>
               </a:defRPr>
             </a:pPr>
             <a:r>
-              <a:t>Not a fixed penalty. It grows with truncation on every buffer we have tried.</a:t>
+              <a:t>•  50 Ω, 0 pF     +6.7 ps        −277.8 ps</a:t>
+            </a:r>
+          </a:p>
+          <a:p>
+            <a:pPr>
+              <a:spcAft>
+                <a:spcPts val="300"/>
+              </a:spcAft>
+              <a:defRPr sz="1700">
+                <a:solidFill>
+                  <a:srgbClr val="191F1C"/>
+                </a:solidFill>
+                <a:latin typeface="Aptos"/>
+              </a:defRPr>
+            </a:pPr>
+            <a:r>
+              <a:t>•  500 Ω, 2 pF    −0.2 ps          −0.9 ps</a:t>
+            </a:r>
+          </a:p>
+          <a:p>
+            <a:pPr>
+              <a:spcAft>
+                <a:spcPts val="300"/>
+              </a:spcAft>
+              <a:defRPr sz="1700">
+                <a:solidFill>
+                  <a:srgbClr val="191F1C"/>
+                </a:solidFill>
+                <a:latin typeface="Aptos"/>
+              </a:defRPr>
+            </a:pPr>
+            <a:r>
+              <a:t>•  1 kΩ, 5 pF     −1.3 ps          −1.1 ps</a:t>
+            </a:r>
+          </a:p>
+        </p:txBody>
+      </p:sp>
+      <p:sp>
+        <p:nvSpPr>
+          <p:cNvPr id="7" name="TextBox 6"/>
+          <p:cNvSpPr txBox="1"/>
+          <p:nvPr/>
+        </p:nvSpPr>
+        <p:spPr>
+          <a:xfrm>
+            <a:off x="640080" y="4480560"/>
+            <a:ext cx="10972800" cy="1005840"/>
+          </a:xfrm>
+          <a:prstGeom prst="rect">
+            <a:avLst/>
+          </a:prstGeom>
+          <a:noFill/>
+        </p:spPr>
+        <p:txBody>
+          <a:bodyPr wrap="square" lIns="45720" rIns="45720" anchor="t">
+            <a:spAutoFit/>
+          </a:bodyPr>
+          <a:lstStyle/>
+          <a:p>
+            <a:pPr algn="l">
+              <a:defRPr sz="1700" b="0">
+                <a:solidFill>
+                  <a:srgbClr val="191F1C"/>
+                </a:solidFill>
+                <a:latin typeface="Aptos"/>
+              </a:defRPr>
+            </a:pPr>
+            <a:r>
+              <a:t>I had this backwards at first. I misapplied the book's double-counting diagnostic and reported that our model over-applies C_comp; the golden-waveform test overturned it.</a:t>
             </a:r>
           </a:p>
         </p:txBody>

</xml_diff>

<commit_message>
Repair the fixture notes block and rebuild the deck
The previous commit left build_0902_meeting_deck.py with a SyntaxError -- a
heredoc turned escaped newlines inside the presenter-notes string into real ones,
so the deck never rebuilt and the render used the stale file. Notes rewritten as
single-line literals; deck rebuilt at 16 slides.

Co-Authored-By: Claude Opus 5 <noreply@anthropic.com>
</commit_message>
<xml_diff>
--- a/results/meeting_deck_2026-09-04/ibis_pybis_status_2026-09-04.pptx
+++ b/results/meeting_deck_2026-09-04/ibis_pybis_status_2026-09-04.pptx
@@ -1232,7 +1232,7 @@
           <a:lstStyle/>
           <a:p>
             <a:r>
-              <a:t>The control reproduces the shipped solve to 2.4e-08, so the method is exact. In quiet regions Ku is load-independent to four decimals, which is the point: the extraction is a device property, not a fixture artifact. On io_buf the mean Ku error is 0.011 for C alone, 0.14-0.16 for L, and the worst-case excursion reaches 7.9 on L 2 nH. Practical rule: avoid a resonant fixture when characterising.</a:t>
+              <a:t>The control reproduces the shipped solve to 2.4e-08, so the method is exact, and in the quiet regions Ku is load-independent to four decimals -- the extraction really is a device property, not a fixture artifact.  Ku RMSE against the R-only baseline:  io_buf C 0.011 / L0.5 0.142 / L2 0.164 / L+C 0.159;  inv_chain C 0.007 / L0.5 0.004 / L2 0.007 / L+C 0.009;  ex2 C 0.028 / L0.5 0.008 / L2 0.022 / L+C 0.032.  Correction worth stating: the plan says added L and C are safe individually and the resonant combination is the problem. The measurement does not support that. On io_buf L alone is the worst case (0.164, peak 7.9) and L+C is no worse (0.159, peak 5.2); on the other two devices everything stays under 0.03. The real rule is that series inductance disturbs the solve, by an amount that depends on the buffer.</a:t>
             </a:r>
           </a:p>
         </p:txBody>
@@ -4243,7 +4243,7 @@
               </a:defRPr>
             </a:pPr>
             <a:r>
-              <a:t>•  Ku re-solved on five different characterisation fixtures, against the R-only baseline. Through the transition all five sit on top of each other.</a:t>
+              <a:t>•  Ku re-solved on five characterisation fixtures against the R-only baseline. Through the transition all five sit on top of each other, and in the quiet regions they agree to four decimals.</a:t>
             </a:r>
           </a:p>
           <a:p>
@@ -4259,7 +4259,7 @@
               </a:defRPr>
             </a:pPr>
             <a:r>
-              <a:t>•  The resonant L+C fixture rings for nanoseconds after the reversal; L and C on their own do not.</a:t>
+              <a:t>•  Series inductance is what disturbs it, and only on io_buf: Ku RMSE 0.14–0.16 with excursions to 7.9, against ≤0.03 on inv_chain and ex2.</a:t>
             </a:r>
           </a:p>
         </p:txBody>

</xml_diff>

<commit_message>
Shorten the fixture bullets so they clear the figures
The second bullet wrapped to a third line and ran under the figure boxes, cutting
off mid-sentence. The RMSE detail moves to the presenter notes, where it already
lives in full.

Co-Authored-By: Claude Opus 5 <noreply@anthropic.com>
</commit_message>
<xml_diff>
--- a/results/meeting_deck_2026-09-04/ibis_pybis_status_2026-09-04.pptx
+++ b/results/meeting_deck_2026-09-04/ibis_pybis_status_2026-09-04.pptx
@@ -4243,7 +4243,7 @@
               </a:defRPr>
             </a:pPr>
             <a:r>
-              <a:t>•  Ku re-solved on five characterisation fixtures against the R-only baseline. Through the transition all five sit on top of each other, and in the quiet regions they agree to four decimals.</a:t>
+              <a:t>•  Five fixtures, Ku re-solved on each. In the quiet regions all five agree to four decimals.</a:t>
             </a:r>
           </a:p>
           <a:p>
@@ -4259,7 +4259,7 @@
               </a:defRPr>
             </a:pPr>
             <a:r>
-              <a:t>•  Series inductance is what disturbs it, and only on io_buf: Ku RMSE 0.14–0.16 with excursions to 7.9, against ≤0.03 on inv_chain and ex2.</a:t>
+              <a:t>•  Series inductance disturbs it, and only on io_buf.</a:t>
             </a:r>
           </a:p>
         </p:txBody>

</xml_diff>